<commit_message>
Referent Markus Warscher eintragen
Namen auf Folien (1, 2, 39), Trainerhandbuch-Deckblatt und Infoblatt (Web/PDF)
eingesetzt. Persönliche Story-Passagen bleiben Platzhalter.

Co-Authored-By: Claude Opus 4.8 <noreply@anthropic.com>
Claude-Session: https://claude.ai/code/session_01GYepHDnc6PQdCAJVNphDNw
</commit_message>
<xml_diff>
--- a/workshop-psychische-gesundheit/Foliensatz_Man-sieht-es-mir-nicht-an.pptx
+++ b/workshop-psychische-gesundheit/Foliensatz_Man-sieht-es-mir-nicht-an.pptx
@@ -4778,7 +4778,7 @@
                 <a:ea typeface="Calibri" pitchFamily="34" charset="-122"/>
                 <a:cs typeface="Calibri" pitchFamily="34" charset="-120"/>
               </a:rPr>
-              <a:t>Referent:  ____________________________</a:t>
+              <a:t>Referent:  Markus Warscher</a:t>
             </a:r>
             <a:endParaRPr lang="en-US" sz="1300" dirty="0"/>
           </a:p>
@@ -12199,7 +12199,7 @@
                   <a:srgbClr val="233139"/>
                 </a:solidFill>
               </a:rPr>
-              <a:t>Mein Name ist … und ich bin heute Ihr Begleiter durch dieses Thema.
+              <a:t>Mein Name ist Markus Warscher, und ich bin heute Ihr Begleiter durch dieses Thema.
 </a:t>
             </a:r>
             <a:endParaRPr lang="en-US" sz="1600" dirty="0"/>
@@ -27926,7 +27926,7 @@
                 <a:ea typeface="Calibri" pitchFamily="34" charset="-122"/>
                 <a:cs typeface="Calibri" pitchFamily="34" charset="-120"/>
               </a:rPr>
-              <a:t>Referent:  ____________________     ·     Kontakt:  ____________________</a:t>
+              <a:t>Referent:  Markus Warscher     ·     Kontakt:  ____________________</a:t>
             </a:r>
             <a:endParaRPr lang="en-US" sz="1300" dirty="0"/>
           </a:p>

</xml_diff>

<commit_message>
Referentenfoto von Markus Warscher einbauen
- Folie 2 „Über mich“: Portrait im linken Panel
- Titelfolie: rundes Referentenfoto bei der Namenszeile
- Infoblatt (Web/PDF): „Ihr Referent“-Block mit Foto und Kurzvorstellung

Co-Authored-By: Claude Opus 4.8 <noreply@anthropic.com>
Claude-Session: https://claude.ai/code/session_01GYepHDnc6PQdCAJVNphDNw
</commit_message>
<xml_diff>
--- a/workshop-psychische-gesundheit/Foliensatz_Man-sieht-es-mir-nicht-an.pptx
+++ b/workshop-psychische-gesundheit/Foliensatz_Man-sieht-es-mir-nicht-an.pptx
@@ -4839,16 +4839,40 @@
           </a:p>
         </p:txBody>
       </p:sp>
-      <p:sp>
-        <p:nvSpPr>
-          <p:cNvPr id="10" name="Text 6"/>
-          <p:cNvSpPr/>
-          <p:nvPr/>
-        </p:nvSpPr>
-        <p:spPr>
-          <a:xfrm>
-            <a:off x="566928" y="5897880"/>
-            <a:ext cx="8229600" cy="365760"/>
+      <p:pic>
+        <p:nvPicPr>
+          <p:cNvPr id="10" name="Image 2" descr="/tmp/claude-0/-home-user-spanwerk-datenschutz/aecddc76-056b-54e2-a906-9229bc8dda84/scratchpad/final/referent_round.jpg">    </p:cNvPr>
+          <p:cNvPicPr>
+            <a:picLocks noChangeAspect="1"/>
+          </p:cNvPicPr>
+          <p:nvPr/>
+        </p:nvPicPr>
+        <p:blipFill>
+          <a:blip r:embed="rId3"/>
+          <a:stretch>
+            <a:fillRect/>
+          </a:stretch>
+        </p:blipFill>
+        <p:spPr>
+          <a:xfrm>
+            <a:off x="566928" y="5623560"/>
+            <a:ext cx="777240" cy="777240"/>
+          </a:xfrm>
+          <a:prstGeom prst="ellipse">
+            <a:avLst/>
+          </a:prstGeom>
+        </p:spPr>
+      </p:pic>
+      <p:sp>
+        <p:nvSpPr>
+          <p:cNvPr id="11" name="Text 6"/>
+          <p:cNvSpPr/>
+          <p:nvPr/>
+        </p:nvSpPr>
+        <p:spPr>
+          <a:xfrm>
+            <a:off x="1527048" y="5623560"/>
+            <a:ext cx="7315200" cy="777240"/>
           </a:xfrm>
           <a:prstGeom prst="rect">
             <a:avLst/>
@@ -4861,6 +4885,9 @@
           <a:lstStyle/>
           <a:p>
             <a:pPr indent="0" marL="0">
+              <a:lnSpc>
+                <a:spcPts val="1900"/>
+              </a:lnSpc>
               <a:buNone/>
             </a:pPr>
             <a:r>
@@ -4872,15 +4899,35 @@
                 <a:ea typeface="Calibri" pitchFamily="34" charset="-122"/>
                 <a:cs typeface="Calibri" pitchFamily="34" charset="-120"/>
               </a:rPr>
-              <a:t>Ein Erlebnis-Workshop mit Markus Warscher</a:t>
+              <a:t>Ein Erlebnis-Workshop mit</a:t>
             </a:r>
             <a:endParaRPr lang="en-US" sz="1500" dirty="0"/>
           </a:p>
-        </p:txBody>
-      </p:sp>
-      <p:sp>
-        <p:nvSpPr>
-          <p:cNvPr id="12" name="Text 7"/>
+          <a:p>
+            <a:pPr indent="0" marL="0">
+              <a:lnSpc>
+                <a:spcPts val="1900"/>
+              </a:lnSpc>
+              <a:buNone/>
+            </a:pPr>
+            <a:r>
+              <a:rPr lang="en-US" sz="1500" i="1" dirty="0">
+                <a:solidFill>
+                  <a:srgbClr val="EAF6EF"/>
+                </a:solidFill>
+                <a:latin typeface="Calibri" pitchFamily="34" charset="0"/>
+                <a:ea typeface="Calibri" pitchFamily="34" charset="-122"/>
+                <a:cs typeface="Calibri" pitchFamily="34" charset="-120"/>
+              </a:rPr>
+              <a:t>Markus Warscher</a:t>
+            </a:r>
+            <a:endParaRPr lang="en-US" sz="1500" dirty="0"/>
+          </a:p>
+        </p:txBody>
+      </p:sp>
+      <p:sp>
+        <p:nvSpPr>
+          <p:cNvPr id="13" name="Text 7"/>
           <p:cNvSpPr/>
           <p:nvPr/>
         </p:nvSpPr>
@@ -4919,7 +4966,7 @@
       </p:sp>
       <p:sp>
         <p:nvSpPr>
-          <p:cNvPr id="13" name="Text 8"/>
+          <p:cNvPr id="14" name="Text 8"/>
           <p:cNvSpPr/>
           <p:nvPr/>
         </p:nvSpPr>
@@ -12341,49 +12388,9 @@
           <a:chExt cx="0" cy="0"/>
         </a:xfrm>
       </p:grpSpPr>
-      <p:sp>
-        <p:nvSpPr>
-          <p:cNvPr id="2" name="Shape 0"/>
-          <p:cNvSpPr/>
-          <p:nvPr/>
-        </p:nvSpPr>
-        <p:spPr>
-          <a:xfrm>
-            <a:off x="0" y="0"/>
-            <a:ext cx="4663440" cy="6858000"/>
-          </a:xfrm>
-          <a:prstGeom prst="rect">
-            <a:avLst/>
-          </a:prstGeom>
-          <a:solidFill>
-            <a:srgbClr val="2C7A6B"/>
-          </a:solidFill>
-          <a:ln/>
-        </p:spPr>
-      </p:sp>
-      <p:sp>
-        <p:nvSpPr>
-          <p:cNvPr id="3" name="Shape 1"/>
-          <p:cNvSpPr/>
-          <p:nvPr/>
-        </p:nvSpPr>
-        <p:spPr>
-          <a:xfrm>
-            <a:off x="1280160" y="1371600"/>
-            <a:ext cx="1280160" cy="1280160"/>
-          </a:xfrm>
-          <a:prstGeom prst="ellipse">
-            <a:avLst/>
-          </a:prstGeom>
-          <a:solidFill>
-            <a:srgbClr val="E89A45"/>
-          </a:solidFill>
-          <a:ln/>
-        </p:spPr>
-      </p:sp>
       <p:pic>
         <p:nvPicPr>
-          <p:cNvPr id="4" name="Image 0" descr="preencoded.png">    </p:cNvPr>
+          <p:cNvPr id="2" name="Image 0" descr="/tmp/claude-0/-home-user-spanwerk-datenschutz/aecddc76-056b-54e2-a906-9229bc8dda84/scratchpad/final/referent_portrait.jpg">    </p:cNvPr>
           <p:cNvPicPr>
             <a:picLocks noChangeAspect="1"/>
           </p:cNvPicPr>
@@ -12391,14 +12398,13 @@
         </p:nvPicPr>
         <p:blipFill>
           <a:blip r:embed="rId1"/>
-          <a:stretch>
-            <a:fillRect/>
-          </a:stretch>
+          <a:srcRect l="0" r="0" t="0" b="0"/>
+          <a:stretch/>
         </p:blipFill>
         <p:spPr>
           <a:xfrm>
-            <a:off x="1613002" y="1704442"/>
-            <a:ext cx="614477" cy="614477"/>
+            <a:off x="0" y="0"/>
+            <a:ext cx="4297680" cy="6858000"/>
           </a:xfrm>
           <a:prstGeom prst="rect">
             <a:avLst/>
@@ -12407,14 +12413,36 @@
       </p:pic>
       <p:sp>
         <p:nvSpPr>
-          <p:cNvPr id="5" name="Text 2"/>
-          <p:cNvSpPr/>
-          <p:nvPr/>
-        </p:nvSpPr>
-        <p:spPr>
-          <a:xfrm>
-            <a:off x="685800" y="2926080"/>
-            <a:ext cx="3657600" cy="2011680"/>
+          <p:cNvPr id="3" name="Shape 0"/>
+          <p:cNvSpPr/>
+          <p:nvPr/>
+        </p:nvSpPr>
+        <p:spPr>
+          <a:xfrm>
+            <a:off x="0" y="4709160"/>
+            <a:ext cx="4297680" cy="2148840"/>
+          </a:xfrm>
+          <a:prstGeom prst="rect">
+            <a:avLst/>
+          </a:prstGeom>
+          <a:solidFill>
+            <a:srgbClr val="24685C">
+              <a:alpha val="88000"/>
+            </a:srgbClr>
+          </a:solidFill>
+          <a:ln/>
+        </p:spPr>
+      </p:sp>
+      <p:sp>
+        <p:nvSpPr>
+          <p:cNvPr id="4" name="Text 1"/>
+          <p:cNvSpPr/>
+          <p:nvPr/>
+        </p:nvSpPr>
+        <p:spPr>
+          <a:xfrm>
+            <a:off x="365760" y="5029200"/>
+            <a:ext cx="3611880" cy="1371600"/>
           </a:xfrm>
           <a:prstGeom prst="rect">
             <a:avLst/>
@@ -12428,12 +12456,12 @@
           <a:p>
             <a:pPr indent="0" marL="0">
               <a:lnSpc>
-                <a:spcPts val="3000"/>
+                <a:spcPts val="2300"/>
               </a:lnSpc>
               <a:buNone/>
             </a:pPr>
             <a:r>
-              <a:rPr lang="en-US" sz="2200" i="1" dirty="0">
+              <a:rPr lang="en-US" sz="1700" i="1" dirty="0">
                 <a:solidFill>
                   <a:srgbClr val="FFFFFF"/>
                 </a:solidFill>
@@ -12441,19 +12469,19 @@
                 <a:ea typeface="Cambria" pitchFamily="34" charset="-122"/>
                 <a:cs typeface="Cambria" pitchFamily="34" charset="-120"/>
               </a:rPr>
-              <a:t>„Ich erzähle Ihnen heute</a:t>
-            </a:r>
-            <a:endParaRPr lang="en-US" sz="2200" dirty="0"/>
+              <a:t>„Ich erzähle Ihnen heute nichts,</a:t>
+            </a:r>
+            <a:endParaRPr lang="en-US" sz="1700" dirty="0"/>
           </a:p>
           <a:p>
             <a:pPr indent="0" marL="0">
               <a:lnSpc>
-                <a:spcPts val="3000"/>
+                <a:spcPts val="2300"/>
               </a:lnSpc>
               <a:buNone/>
             </a:pPr>
             <a:r>
-              <a:rPr lang="en-US" sz="2200" i="1" dirty="0">
+              <a:rPr lang="en-US" sz="1700" i="1" dirty="0">
                 <a:solidFill>
                   <a:srgbClr val="FFFFFF"/>
                 </a:solidFill>
@@ -12461,68 +12489,87 @@
                 <a:ea typeface="Cambria" pitchFamily="34" charset="-122"/>
                 <a:cs typeface="Cambria" pitchFamily="34" charset="-120"/>
               </a:rPr>
-              <a:t>nichts, was ich nicht</a:t>
-            </a:r>
-            <a:endParaRPr lang="en-US" sz="2200" dirty="0"/>
-          </a:p>
+              <a:t>was ich nicht selbst erlebt habe.“</a:t>
+            </a:r>
+            <a:endParaRPr lang="en-US" sz="1700" dirty="0"/>
+          </a:p>
+        </p:txBody>
+      </p:sp>
+      <p:sp>
+        <p:nvSpPr>
+          <p:cNvPr id="5" name="Text 2"/>
+          <p:cNvSpPr/>
+          <p:nvPr/>
+        </p:nvSpPr>
+        <p:spPr>
+          <a:xfrm>
+            <a:off x="4709160" y="548640"/>
+            <a:ext cx="6766560" cy="310896"/>
+          </a:xfrm>
+          <a:prstGeom prst="rect">
+            <a:avLst/>
+          </a:prstGeom>
+          <a:noFill/>
+          <a:ln/>
+        </p:spPr>
+        <p:txBody>
+          <a:bodyPr wrap="square" rtlCol="0" anchor="ctr"/>
+          <a:lstStyle/>
           <a:p>
             <a:pPr indent="0" marL="0">
-              <a:lnSpc>
-                <a:spcPts val="3000"/>
-              </a:lnSpc>
-              <a:buNone/>
-            </a:pPr>
-            <a:r>
-              <a:rPr lang="en-US" sz="2200" i="1" dirty="0">
-                <a:solidFill>
-                  <a:srgbClr val="FFFFFF"/>
+              <a:buNone/>
+            </a:pPr>
+            <a:r>
+              <a:rPr lang="en-US" sz="1300" b="1" spc="200" kern="0" dirty="0">
+                <a:solidFill>
+                  <a:srgbClr val="BC722A"/>
+                </a:solidFill>
+                <a:latin typeface="Calibri" pitchFamily="34" charset="0"/>
+                <a:ea typeface="Calibri" pitchFamily="34" charset="-122"/>
+                <a:cs typeface="Calibri" pitchFamily="34" charset="-120"/>
+              </a:rPr>
+              <a:t>WER HEUTE VOR IHNEN STEHT</a:t>
+            </a:r>
+            <a:endParaRPr lang="en-US" sz="1300" dirty="0"/>
+          </a:p>
+        </p:txBody>
+      </p:sp>
+      <p:sp>
+        <p:nvSpPr>
+          <p:cNvPr id="6" name="Text 3"/>
+          <p:cNvSpPr/>
+          <p:nvPr/>
+        </p:nvSpPr>
+        <p:spPr>
+          <a:xfrm>
+            <a:off x="4709160" y="841248"/>
+            <a:ext cx="6766560" cy="731520"/>
+          </a:xfrm>
+          <a:prstGeom prst="rect">
+            <a:avLst/>
+          </a:prstGeom>
+          <a:noFill/>
+          <a:ln/>
+        </p:spPr>
+        <p:txBody>
+          <a:bodyPr wrap="square" rtlCol="0" anchor="ctr"/>
+          <a:lstStyle/>
+          <a:p>
+            <a:pPr indent="0" marL="0">
+              <a:buNone/>
+            </a:pPr>
+            <a:r>
+              <a:rPr lang="en-US" sz="3400" b="1" dirty="0">
+                <a:solidFill>
+                  <a:srgbClr val="2C7A6B"/>
                 </a:solidFill>
                 <a:latin typeface="Cambria" pitchFamily="34" charset="0"/>
                 <a:ea typeface="Cambria" pitchFamily="34" charset="-122"/>
                 <a:cs typeface="Cambria" pitchFamily="34" charset="-120"/>
               </a:rPr>
-              <a:t>selbst erlebt habe.“</a:t>
-            </a:r>
-            <a:endParaRPr lang="en-US" sz="2200" dirty="0"/>
-          </a:p>
-        </p:txBody>
-      </p:sp>
-      <p:sp>
-        <p:nvSpPr>
-          <p:cNvPr id="6" name="Text 3"/>
-          <p:cNvSpPr/>
-          <p:nvPr/>
-        </p:nvSpPr>
-        <p:spPr>
-          <a:xfrm>
-            <a:off x="566928" y="438912"/>
-            <a:ext cx="11057839" cy="310896"/>
-          </a:xfrm>
-          <a:prstGeom prst="rect">
-            <a:avLst/>
-          </a:prstGeom>
-          <a:noFill/>
-          <a:ln/>
-        </p:spPr>
-        <p:txBody>
-          <a:bodyPr wrap="square" rtlCol="0" anchor="ctr"/>
-          <a:lstStyle/>
-          <a:p>
-            <a:pPr algn="l" indent="0" marL="0">
-              <a:buNone/>
-            </a:pPr>
-            <a:r>
-              <a:rPr lang="en-US" sz="1300" b="1" spc="200" kern="0" dirty="0">
-                <a:solidFill>
-                  <a:srgbClr val="BC722A"/>
-                </a:solidFill>
-                <a:latin typeface="Calibri" pitchFamily="34" charset="0"/>
-                <a:ea typeface="Calibri" pitchFamily="34" charset="-122"/>
-                <a:cs typeface="Calibri" pitchFamily="34" charset="-120"/>
-              </a:rPr>
-              <a:t>WER HEUTE VOR IHNEN STEHT</a:t>
-            </a:r>
-            <a:endParaRPr lang="en-US" sz="1300" dirty="0"/>
+              <a:t>Über mich</a:t>
+            </a:r>
+            <a:endParaRPr lang="en-US" sz="3400" dirty="0"/>
           </a:p>
         </p:txBody>
       </p:sp>
@@ -12534,47 +12581,8 @@
         </p:nvSpPr>
         <p:spPr>
           <a:xfrm>
-            <a:off x="566928" y="731520"/>
-            <a:ext cx="11057839" cy="731520"/>
-          </a:xfrm>
-          <a:prstGeom prst="rect">
-            <a:avLst/>
-          </a:prstGeom>
-          <a:noFill/>
-          <a:ln/>
-        </p:spPr>
-        <p:txBody>
-          <a:bodyPr wrap="square" rtlCol="0" anchor="ctr"/>
-          <a:lstStyle/>
-          <a:p>
-            <a:pPr algn="l" indent="0" marL="0">
-              <a:buNone/>
-            </a:pPr>
-            <a:r>
-              <a:rPr lang="en-US" sz="3400" b="1" dirty="0">
-                <a:solidFill>
-                  <a:srgbClr val="2C7A6B"/>
-                </a:solidFill>
-                <a:latin typeface="Cambria" pitchFamily="34" charset="0"/>
-                <a:ea typeface="Cambria" pitchFamily="34" charset="-122"/>
-                <a:cs typeface="Cambria" pitchFamily="34" charset="-120"/>
-              </a:rPr>
-              <a:t>Über mich</a:t>
-            </a:r>
-            <a:endParaRPr lang="en-US" sz="3400" dirty="0"/>
-          </a:p>
-        </p:txBody>
-      </p:sp>
-      <p:sp>
-        <p:nvSpPr>
-          <p:cNvPr id="8" name="Text 5"/>
-          <p:cNvSpPr/>
-          <p:nvPr/>
-        </p:nvSpPr>
-        <p:spPr>
-          <a:xfrm>
-            <a:off x="5029200" y="1554480"/>
-            <a:ext cx="6583680" cy="4206240"/>
+            <a:off x="4709160" y="1737360"/>
+            <a:ext cx="6766560" cy="4114800"/>
           </a:xfrm>
           <a:prstGeom prst="rect">
             <a:avLst/>
@@ -12657,7 +12665,7 @@
       </p:sp>
       <p:sp>
         <p:nvSpPr>
-          <p:cNvPr id="10" name="Text 6"/>
+          <p:cNvPr id="9" name="Text 5"/>
           <p:cNvSpPr/>
           <p:nvPr/>
         </p:nvSpPr>
@@ -12696,7 +12704,7 @@
       </p:sp>
       <p:sp>
         <p:nvSpPr>
-          <p:cNvPr id="11" name="Text 7"/>
+          <p:cNvPr id="10" name="Text 6"/>
           <p:cNvSpPr/>
           <p:nvPr/>
         </p:nvSpPr>

</xml_diff>

<commit_message>
Lesbarkeit sichern: Transparenzen entfernt, Bilder fest eingedunkelt
Ursache der blassen/schwer lesbaren Stellen waren halbtransparente Flächen über
Fotos (uneinheitliche Darstellung je nach Programm). Behoben:
- Hintergrund- und Panel-Bilder fest eingedunkelt (deckend) statt Overlay
- alle Textkacheln vollständig deckend, Textfarben auf Kontrast geprüft
- weißer Text auf Bildern per Kontrast-Test verifiziert

Co-Authored-By: Claude Opus 4.8 <noreply@anthropic.com>
Claude-Session: https://claude.ai/code/session_01GYepHDnc6PQdCAJVNphDNw
</commit_message>
<xml_diff>
--- a/workshop-psychische-gesundheit/Foliensatz_Man-sieht-es-mir-nicht-an.pptx
+++ b/workshop-psychische-gesundheit/Foliensatz_Man-sieht-es-mir-nicht-an.pptx
@@ -4567,7 +4567,7 @@
       </p:grpSpPr>
       <p:pic>
         <p:nvPicPr>
-          <p:cNvPr id="2" name="Image 0" descr="/tmp/claude-0/-home-user-spanwerk-datenschutz/aecddc76-056b-54e2-a906-9229bc8dda84/scratchpad/final/bg_titel.jpg">    </p:cNvPr>
+          <p:cNvPr id="2" name="Image 0" descr="/tmp/claude-0/-home-user-spanwerk-datenschutz/aecddc76-056b-54e2-a906-9229bc8dda84/scratchpad/final/bg_titel_dark.jpg">    </p:cNvPr>
           <p:cNvPicPr>
             <a:picLocks noChangeAspect="1"/>
           </p:cNvPicPr>
@@ -4596,50 +4596,6 @@
         </p:nvSpPr>
         <p:spPr>
           <a:xfrm>
-            <a:off x="0" y="0"/>
-            <a:ext cx="12191695" cy="6858000"/>
-          </a:xfrm>
-          <a:prstGeom prst="rect">
-            <a:avLst/>
-          </a:prstGeom>
-          <a:solidFill>
-            <a:srgbClr val="24685C">
-              <a:alpha val="78000"/>
-            </a:srgbClr>
-          </a:solidFill>
-          <a:ln/>
-        </p:spPr>
-      </p:sp>
-      <p:sp>
-        <p:nvSpPr>
-          <p:cNvPr id="4" name="Shape 1"/>
-          <p:cNvSpPr/>
-          <p:nvPr/>
-        </p:nvSpPr>
-        <p:spPr>
-          <a:xfrm>
-            <a:off x="0" y="0"/>
-            <a:ext cx="7863840" cy="6858000"/>
-          </a:xfrm>
-          <a:prstGeom prst="rect">
-            <a:avLst/>
-          </a:prstGeom>
-          <a:solidFill>
-            <a:srgbClr val="24685C">
-              <a:alpha val="80000"/>
-            </a:srgbClr>
-          </a:solidFill>
-          <a:ln/>
-        </p:spPr>
-      </p:sp>
-      <p:sp>
-        <p:nvSpPr>
-          <p:cNvPr id="5" name="Shape 2"/>
-          <p:cNvSpPr/>
-          <p:nvPr/>
-        </p:nvSpPr>
-        <p:spPr>
-          <a:xfrm>
             <a:off x="566928" y="868680"/>
             <a:ext cx="868680" cy="868680"/>
           </a:xfrm>
@@ -4654,7 +4610,7 @@
       </p:sp>
       <p:pic>
         <p:nvPicPr>
-          <p:cNvPr id="6" name="Image 1" descr="preencoded.png">    </p:cNvPr>
+          <p:cNvPr id="4" name="Image 1" descr="preencoded.png">    </p:cNvPr>
           <p:cNvPicPr>
             <a:picLocks noChangeAspect="1"/>
           </p:cNvPicPr>
@@ -4678,7 +4634,7 @@
       </p:pic>
       <p:sp>
         <p:nvSpPr>
-          <p:cNvPr id="7" name="Text 3"/>
+          <p:cNvPr id="5" name="Text 1"/>
           <p:cNvSpPr/>
           <p:nvPr/>
         </p:nvSpPr>
@@ -4717,7 +4673,7 @@
       </p:sp>
       <p:sp>
         <p:nvSpPr>
-          <p:cNvPr id="8" name="Text 4"/>
+          <p:cNvPr id="6" name="Text 2"/>
           <p:cNvSpPr/>
           <p:nvPr/>
         </p:nvSpPr>
@@ -4779,7 +4735,7 @@
       </p:sp>
       <p:sp>
         <p:nvSpPr>
-          <p:cNvPr id="9" name="Text 5"/>
+          <p:cNvPr id="7" name="Text 3"/>
           <p:cNvSpPr/>
           <p:nvPr/>
         </p:nvSpPr>
@@ -4841,7 +4797,7 @@
       </p:sp>
       <p:pic>
         <p:nvPicPr>
-          <p:cNvPr id="10" name="Image 2" descr="/tmp/claude-0/-home-user-spanwerk-datenschutz/aecddc76-056b-54e2-a906-9229bc8dda84/scratchpad/final/referent_round.jpg">    </p:cNvPr>
+          <p:cNvPr id="8" name="Image 2" descr="/tmp/claude-0/-home-user-spanwerk-datenschutz/aecddc76-056b-54e2-a906-9229bc8dda84/scratchpad/final/referent_round.jpg">    </p:cNvPr>
           <p:cNvPicPr>
             <a:picLocks noChangeAspect="1"/>
           </p:cNvPicPr>
@@ -4865,7 +4821,7 @@
       </p:pic>
       <p:sp>
         <p:nvSpPr>
-          <p:cNvPr id="11" name="Text 6"/>
+          <p:cNvPr id="9" name="Text 4"/>
           <p:cNvSpPr/>
           <p:nvPr/>
         </p:nvSpPr>
@@ -4927,7 +4883,7 @@
       </p:sp>
       <p:sp>
         <p:nvSpPr>
-          <p:cNvPr id="13" name="Text 7"/>
+          <p:cNvPr id="11" name="Text 5"/>
           <p:cNvSpPr/>
           <p:nvPr/>
         </p:nvSpPr>
@@ -4966,7 +4922,7 @@
       </p:sp>
       <p:sp>
         <p:nvSpPr>
-          <p:cNvPr id="14" name="Text 8"/>
+          <p:cNvPr id="12" name="Text 6"/>
           <p:cNvSpPr/>
           <p:nvPr/>
         </p:nvSpPr>
@@ -6005,7 +5961,7 @@
       </p:grpSpPr>
       <p:pic>
         <p:nvPicPr>
-          <p:cNvPr id="2" name="Image 0" descr="/tmp/claude-0/-home-user-spanwerk-datenschutz/aecddc76-056b-54e2-a906-9229bc8dda84/scratchpad/final/img_depression.jpg">    </p:cNvPr>
+          <p:cNvPr id="2" name="Image 0" descr="/tmp/claude-0/-home-user-spanwerk-datenschutz/aecddc76-056b-54e2-a906-9229bc8dda84/scratchpad/final/img_depression_panel.jpg">    </p:cNvPr>
           <p:cNvPicPr>
             <a:picLocks noChangeAspect="1"/>
           </p:cNvPicPr>
@@ -6034,50 +5990,6 @@
         </p:nvSpPr>
         <p:spPr>
           <a:xfrm>
-            <a:off x="0" y="0"/>
-            <a:ext cx="4206240" cy="6858000"/>
-          </a:xfrm>
-          <a:prstGeom prst="rect">
-            <a:avLst/>
-          </a:prstGeom>
-          <a:solidFill>
-            <a:srgbClr val="2C7A6B">
-              <a:alpha val="72000"/>
-            </a:srgbClr>
-          </a:solidFill>
-          <a:ln/>
-        </p:spPr>
-      </p:sp>
-      <p:sp>
-        <p:nvSpPr>
-          <p:cNvPr id="4" name="Shape 1"/>
-          <p:cNvSpPr/>
-          <p:nvPr/>
-        </p:nvSpPr>
-        <p:spPr>
-          <a:xfrm>
-            <a:off x="0" y="0"/>
-            <a:ext cx="4206240" cy="2651760"/>
-          </a:xfrm>
-          <a:prstGeom prst="rect">
-            <a:avLst/>
-          </a:prstGeom>
-          <a:solidFill>
-            <a:srgbClr val="2C7A6B">
-              <a:alpha val="92000"/>
-            </a:srgbClr>
-          </a:solidFill>
-          <a:ln/>
-        </p:spPr>
-      </p:sp>
-      <p:sp>
-        <p:nvSpPr>
-          <p:cNvPr id="5" name="Shape 2"/>
-          <p:cNvSpPr/>
-          <p:nvPr/>
-        </p:nvSpPr>
-        <p:spPr>
-          <a:xfrm>
             <a:off x="566928" y="566928"/>
             <a:ext cx="1051560" cy="1051560"/>
           </a:xfrm>
@@ -6092,7 +6004,7 @@
       </p:sp>
       <p:pic>
         <p:nvPicPr>
-          <p:cNvPr id="6" name="Image 1" descr="preencoded.png">    </p:cNvPr>
+          <p:cNvPr id="4" name="Image 1" descr="preencoded.png">    </p:cNvPr>
           <p:cNvPicPr>
             <a:picLocks noChangeAspect="1"/>
           </p:cNvPicPr>
@@ -6116,7 +6028,7 @@
       </p:pic>
       <p:sp>
         <p:nvSpPr>
-          <p:cNvPr id="7" name="Text 3"/>
+          <p:cNvPr id="5" name="Text 1"/>
           <p:cNvSpPr/>
           <p:nvPr/>
         </p:nvSpPr>
@@ -6155,7 +6067,7 @@
       </p:sp>
       <p:sp>
         <p:nvSpPr>
-          <p:cNvPr id="8" name="Shape 4"/>
+          <p:cNvPr id="6" name="Shape 2"/>
           <p:cNvSpPr/>
           <p:nvPr/>
         </p:nvSpPr>
@@ -6170,16 +6082,14 @@
             </a:avLst>
           </a:prstGeom>
           <a:solidFill>
-            <a:srgbClr val="24685C">
-              <a:alpha val="94000"/>
-            </a:srgbClr>
+            <a:srgbClr val="24685C"/>
           </a:solidFill>
           <a:ln/>
         </p:spPr>
       </p:sp>
       <p:sp>
         <p:nvSpPr>
-          <p:cNvPr id="9" name="Text 5"/>
+          <p:cNvPr id="7" name="Text 3"/>
           <p:cNvSpPr/>
           <p:nvPr/>
         </p:nvSpPr>
@@ -6218,7 +6128,7 @@
       </p:sp>
       <p:sp>
         <p:nvSpPr>
-          <p:cNvPr id="10" name="Text 6"/>
+          <p:cNvPr id="8" name="Text 4"/>
           <p:cNvSpPr/>
           <p:nvPr/>
         </p:nvSpPr>
@@ -6257,7 +6167,7 @@
       </p:sp>
       <p:sp>
         <p:nvSpPr>
-          <p:cNvPr id="11" name="Text 7"/>
+          <p:cNvPr id="9" name="Text 5"/>
           <p:cNvSpPr/>
           <p:nvPr/>
         </p:nvSpPr>
@@ -6299,7 +6209,7 @@
       </p:sp>
       <p:sp>
         <p:nvSpPr>
-          <p:cNvPr id="12" name="Text 8"/>
+          <p:cNvPr id="10" name="Text 6"/>
           <p:cNvSpPr/>
           <p:nvPr/>
         </p:nvSpPr>
@@ -6338,7 +6248,7 @@
       </p:sp>
       <p:sp>
         <p:nvSpPr>
-          <p:cNvPr id="13" name="Text 9"/>
+          <p:cNvPr id="11" name="Text 7"/>
           <p:cNvSpPr/>
           <p:nvPr/>
         </p:nvSpPr>
@@ -6377,7 +6287,7 @@
       </p:sp>
       <p:sp>
         <p:nvSpPr>
-          <p:cNvPr id="14" name="Shape 10"/>
+          <p:cNvPr id="12" name="Shape 8"/>
           <p:cNvSpPr/>
           <p:nvPr/>
         </p:nvSpPr>
@@ -6397,7 +6307,7 @@
       </p:sp>
       <p:sp>
         <p:nvSpPr>
-          <p:cNvPr id="15" name="Text 11"/>
+          <p:cNvPr id="13" name="Text 9"/>
           <p:cNvSpPr/>
           <p:nvPr/>
         </p:nvSpPr>
@@ -6456,7 +6366,7 @@
       </p:sp>
       <p:sp>
         <p:nvSpPr>
-          <p:cNvPr id="16" name="Shape 12"/>
+          <p:cNvPr id="14" name="Shape 10"/>
           <p:cNvSpPr/>
           <p:nvPr/>
         </p:nvSpPr>
@@ -6476,7 +6386,7 @@
       </p:sp>
       <p:sp>
         <p:nvSpPr>
-          <p:cNvPr id="17" name="Text 13"/>
+          <p:cNvPr id="15" name="Text 11"/>
           <p:cNvSpPr/>
           <p:nvPr/>
         </p:nvSpPr>
@@ -6535,7 +6445,7 @@
       </p:sp>
       <p:sp>
         <p:nvSpPr>
-          <p:cNvPr id="18" name="Shape 14"/>
+          <p:cNvPr id="16" name="Shape 12"/>
           <p:cNvSpPr/>
           <p:nvPr/>
         </p:nvSpPr>
@@ -6555,7 +6465,7 @@
       </p:sp>
       <p:sp>
         <p:nvSpPr>
-          <p:cNvPr id="19" name="Text 15"/>
+          <p:cNvPr id="17" name="Text 13"/>
           <p:cNvSpPr/>
           <p:nvPr/>
         </p:nvSpPr>
@@ -6614,7 +6524,7 @@
       </p:sp>
       <p:sp>
         <p:nvSpPr>
-          <p:cNvPr id="20" name="Shape 16"/>
+          <p:cNvPr id="18" name="Shape 14"/>
           <p:cNvSpPr/>
           <p:nvPr/>
         </p:nvSpPr>
@@ -6634,7 +6544,7 @@
       </p:sp>
       <p:sp>
         <p:nvSpPr>
-          <p:cNvPr id="21" name="Text 17"/>
+          <p:cNvPr id="19" name="Text 15"/>
           <p:cNvSpPr/>
           <p:nvPr/>
         </p:nvSpPr>
@@ -6693,7 +6603,7 @@
       </p:sp>
       <p:sp>
         <p:nvSpPr>
-          <p:cNvPr id="22" name="Shape 18"/>
+          <p:cNvPr id="20" name="Shape 16"/>
           <p:cNvSpPr/>
           <p:nvPr/>
         </p:nvSpPr>
@@ -6713,7 +6623,7 @@
       </p:sp>
       <p:sp>
         <p:nvSpPr>
-          <p:cNvPr id="23" name="Text 19"/>
+          <p:cNvPr id="21" name="Text 17"/>
           <p:cNvSpPr/>
           <p:nvPr/>
         </p:nvSpPr>
@@ -6772,7 +6682,7 @@
       </p:sp>
       <p:sp>
         <p:nvSpPr>
-          <p:cNvPr id="25" name="Text 20"/>
+          <p:cNvPr id="23" name="Text 18"/>
           <p:cNvSpPr/>
           <p:nvPr/>
         </p:nvSpPr>
@@ -6811,7 +6721,7 @@
       </p:sp>
       <p:sp>
         <p:nvSpPr>
-          <p:cNvPr id="26" name="Text 21"/>
+          <p:cNvPr id="24" name="Text 19"/>
           <p:cNvSpPr/>
           <p:nvPr/>
         </p:nvSpPr>
@@ -6882,7 +6792,7 @@
       </p:grpSpPr>
       <p:pic>
         <p:nvPicPr>
-          <p:cNvPr id="2" name="Image 0" descr="/tmp/claude-0/-home-user-spanwerk-datenschutz/aecddc76-056b-54e2-a906-9229bc8dda84/scratchpad/final/img_angst.jpg">    </p:cNvPr>
+          <p:cNvPr id="2" name="Image 0" descr="/tmp/claude-0/-home-user-spanwerk-datenschutz/aecddc76-056b-54e2-a906-9229bc8dda84/scratchpad/final/img_angst_panel.jpg">    </p:cNvPr>
           <p:cNvPicPr>
             <a:picLocks noChangeAspect="1"/>
           </p:cNvPicPr>
@@ -6911,50 +6821,6 @@
         </p:nvSpPr>
         <p:spPr>
           <a:xfrm>
-            <a:off x="0" y="0"/>
-            <a:ext cx="4206240" cy="6858000"/>
-          </a:xfrm>
-          <a:prstGeom prst="rect">
-            <a:avLst/>
-          </a:prstGeom>
-          <a:solidFill>
-            <a:srgbClr val="2C7A6B">
-              <a:alpha val="72000"/>
-            </a:srgbClr>
-          </a:solidFill>
-          <a:ln/>
-        </p:spPr>
-      </p:sp>
-      <p:sp>
-        <p:nvSpPr>
-          <p:cNvPr id="4" name="Shape 1"/>
-          <p:cNvSpPr/>
-          <p:nvPr/>
-        </p:nvSpPr>
-        <p:spPr>
-          <a:xfrm>
-            <a:off x="0" y="0"/>
-            <a:ext cx="4206240" cy="2651760"/>
-          </a:xfrm>
-          <a:prstGeom prst="rect">
-            <a:avLst/>
-          </a:prstGeom>
-          <a:solidFill>
-            <a:srgbClr val="2C7A6B">
-              <a:alpha val="92000"/>
-            </a:srgbClr>
-          </a:solidFill>
-          <a:ln/>
-        </p:spPr>
-      </p:sp>
-      <p:sp>
-        <p:nvSpPr>
-          <p:cNvPr id="5" name="Shape 2"/>
-          <p:cNvSpPr/>
-          <p:nvPr/>
-        </p:nvSpPr>
-        <p:spPr>
-          <a:xfrm>
             <a:off x="566928" y="566928"/>
             <a:ext cx="1051560" cy="1051560"/>
           </a:xfrm>
@@ -6969,7 +6835,7 @@
       </p:sp>
       <p:pic>
         <p:nvPicPr>
-          <p:cNvPr id="6" name="Image 1" descr="preencoded.png">    </p:cNvPr>
+          <p:cNvPr id="4" name="Image 1" descr="preencoded.png">    </p:cNvPr>
           <p:cNvPicPr>
             <a:picLocks noChangeAspect="1"/>
           </p:cNvPicPr>
@@ -6993,7 +6859,7 @@
       </p:pic>
       <p:sp>
         <p:nvSpPr>
-          <p:cNvPr id="7" name="Text 3"/>
+          <p:cNvPr id="5" name="Text 1"/>
           <p:cNvSpPr/>
           <p:nvPr/>
         </p:nvSpPr>
@@ -7032,7 +6898,7 @@
       </p:sp>
       <p:sp>
         <p:nvSpPr>
-          <p:cNvPr id="8" name="Shape 4"/>
+          <p:cNvPr id="6" name="Shape 2"/>
           <p:cNvSpPr/>
           <p:nvPr/>
         </p:nvSpPr>
@@ -7047,16 +6913,14 @@
             </a:avLst>
           </a:prstGeom>
           <a:solidFill>
-            <a:srgbClr val="24685C">
-              <a:alpha val="94000"/>
-            </a:srgbClr>
+            <a:srgbClr val="24685C"/>
           </a:solidFill>
           <a:ln/>
         </p:spPr>
       </p:sp>
       <p:sp>
         <p:nvSpPr>
-          <p:cNvPr id="9" name="Text 5"/>
+          <p:cNvPr id="7" name="Text 3"/>
           <p:cNvSpPr/>
           <p:nvPr/>
         </p:nvSpPr>
@@ -7095,7 +6959,7 @@
       </p:sp>
       <p:sp>
         <p:nvSpPr>
-          <p:cNvPr id="10" name="Text 6"/>
+          <p:cNvPr id="8" name="Text 4"/>
           <p:cNvSpPr/>
           <p:nvPr/>
         </p:nvSpPr>
@@ -7134,7 +6998,7 @@
       </p:sp>
       <p:sp>
         <p:nvSpPr>
-          <p:cNvPr id="11" name="Text 7"/>
+          <p:cNvPr id="9" name="Text 5"/>
           <p:cNvSpPr/>
           <p:nvPr/>
         </p:nvSpPr>
@@ -7176,7 +7040,7 @@
       </p:sp>
       <p:sp>
         <p:nvSpPr>
-          <p:cNvPr id="12" name="Text 8"/>
+          <p:cNvPr id="10" name="Text 6"/>
           <p:cNvSpPr/>
           <p:nvPr/>
         </p:nvSpPr>
@@ -7215,7 +7079,7 @@
       </p:sp>
       <p:sp>
         <p:nvSpPr>
-          <p:cNvPr id="13" name="Text 9"/>
+          <p:cNvPr id="11" name="Text 7"/>
           <p:cNvSpPr/>
           <p:nvPr/>
         </p:nvSpPr>
@@ -7254,7 +7118,7 @@
       </p:sp>
       <p:sp>
         <p:nvSpPr>
-          <p:cNvPr id="14" name="Shape 10"/>
+          <p:cNvPr id="12" name="Shape 8"/>
           <p:cNvSpPr/>
           <p:nvPr/>
         </p:nvSpPr>
@@ -7274,7 +7138,7 @@
       </p:sp>
       <p:sp>
         <p:nvSpPr>
-          <p:cNvPr id="15" name="Text 11"/>
+          <p:cNvPr id="13" name="Text 9"/>
           <p:cNvSpPr/>
           <p:nvPr/>
         </p:nvSpPr>
@@ -7333,7 +7197,7 @@
       </p:sp>
       <p:sp>
         <p:nvSpPr>
-          <p:cNvPr id="16" name="Shape 12"/>
+          <p:cNvPr id="14" name="Shape 10"/>
           <p:cNvSpPr/>
           <p:nvPr/>
         </p:nvSpPr>
@@ -7353,7 +7217,7 @@
       </p:sp>
       <p:sp>
         <p:nvSpPr>
-          <p:cNvPr id="17" name="Text 13"/>
+          <p:cNvPr id="15" name="Text 11"/>
           <p:cNvSpPr/>
           <p:nvPr/>
         </p:nvSpPr>
@@ -7412,7 +7276,7 @@
       </p:sp>
       <p:sp>
         <p:nvSpPr>
-          <p:cNvPr id="18" name="Shape 14"/>
+          <p:cNvPr id="16" name="Shape 12"/>
           <p:cNvSpPr/>
           <p:nvPr/>
         </p:nvSpPr>
@@ -7432,7 +7296,7 @@
       </p:sp>
       <p:sp>
         <p:nvSpPr>
-          <p:cNvPr id="19" name="Text 15"/>
+          <p:cNvPr id="17" name="Text 13"/>
           <p:cNvSpPr/>
           <p:nvPr/>
         </p:nvSpPr>
@@ -7491,7 +7355,7 @@
       </p:sp>
       <p:sp>
         <p:nvSpPr>
-          <p:cNvPr id="20" name="Shape 16"/>
+          <p:cNvPr id="18" name="Shape 14"/>
           <p:cNvSpPr/>
           <p:nvPr/>
         </p:nvSpPr>
@@ -7511,7 +7375,7 @@
       </p:sp>
       <p:sp>
         <p:nvSpPr>
-          <p:cNvPr id="21" name="Text 17"/>
+          <p:cNvPr id="19" name="Text 15"/>
           <p:cNvSpPr/>
           <p:nvPr/>
         </p:nvSpPr>
@@ -7570,7 +7434,7 @@
       </p:sp>
       <p:sp>
         <p:nvSpPr>
-          <p:cNvPr id="22" name="Shape 18"/>
+          <p:cNvPr id="20" name="Shape 16"/>
           <p:cNvSpPr/>
           <p:nvPr/>
         </p:nvSpPr>
@@ -7590,7 +7454,7 @@
       </p:sp>
       <p:sp>
         <p:nvSpPr>
-          <p:cNvPr id="23" name="Text 19"/>
+          <p:cNvPr id="21" name="Text 17"/>
           <p:cNvSpPr/>
           <p:nvPr/>
         </p:nvSpPr>
@@ -7649,7 +7513,7 @@
       </p:sp>
       <p:sp>
         <p:nvSpPr>
-          <p:cNvPr id="25" name="Text 20"/>
+          <p:cNvPr id="23" name="Text 18"/>
           <p:cNvSpPr/>
           <p:nvPr/>
         </p:nvSpPr>
@@ -7688,7 +7552,7 @@
       </p:sp>
       <p:sp>
         <p:nvSpPr>
-          <p:cNvPr id="26" name="Text 21"/>
+          <p:cNvPr id="24" name="Text 19"/>
           <p:cNvSpPr/>
           <p:nvPr/>
         </p:nvSpPr>
@@ -7759,7 +7623,7 @@
       </p:grpSpPr>
       <p:pic>
         <p:nvPicPr>
-          <p:cNvPr id="2" name="Image 0" descr="/tmp/claude-0/-home-user-spanwerk-datenschutz/aecddc76-056b-54e2-a906-9229bc8dda84/scratchpad/final/img_burnout.jpg">    </p:cNvPr>
+          <p:cNvPr id="2" name="Image 0" descr="/tmp/claude-0/-home-user-spanwerk-datenschutz/aecddc76-056b-54e2-a906-9229bc8dda84/scratchpad/final/img_burnout_panel.jpg">    </p:cNvPr>
           <p:cNvPicPr>
             <a:picLocks noChangeAspect="1"/>
           </p:cNvPicPr>
@@ -7788,50 +7652,6 @@
         </p:nvSpPr>
         <p:spPr>
           <a:xfrm>
-            <a:off x="0" y="0"/>
-            <a:ext cx="4206240" cy="6858000"/>
-          </a:xfrm>
-          <a:prstGeom prst="rect">
-            <a:avLst/>
-          </a:prstGeom>
-          <a:solidFill>
-            <a:srgbClr val="2C7A6B">
-              <a:alpha val="72000"/>
-            </a:srgbClr>
-          </a:solidFill>
-          <a:ln/>
-        </p:spPr>
-      </p:sp>
-      <p:sp>
-        <p:nvSpPr>
-          <p:cNvPr id="4" name="Shape 1"/>
-          <p:cNvSpPr/>
-          <p:nvPr/>
-        </p:nvSpPr>
-        <p:spPr>
-          <a:xfrm>
-            <a:off x="0" y="0"/>
-            <a:ext cx="4206240" cy="2651760"/>
-          </a:xfrm>
-          <a:prstGeom prst="rect">
-            <a:avLst/>
-          </a:prstGeom>
-          <a:solidFill>
-            <a:srgbClr val="2C7A6B">
-              <a:alpha val="92000"/>
-            </a:srgbClr>
-          </a:solidFill>
-          <a:ln/>
-        </p:spPr>
-      </p:sp>
-      <p:sp>
-        <p:nvSpPr>
-          <p:cNvPr id="5" name="Shape 2"/>
-          <p:cNvSpPr/>
-          <p:nvPr/>
-        </p:nvSpPr>
-        <p:spPr>
-          <a:xfrm>
             <a:off x="566928" y="566928"/>
             <a:ext cx="1051560" cy="1051560"/>
           </a:xfrm>
@@ -7846,7 +7666,7 @@
       </p:sp>
       <p:pic>
         <p:nvPicPr>
-          <p:cNvPr id="6" name="Image 1" descr="preencoded.png">    </p:cNvPr>
+          <p:cNvPr id="4" name="Image 1" descr="preencoded.png">    </p:cNvPr>
           <p:cNvPicPr>
             <a:picLocks noChangeAspect="1"/>
           </p:cNvPicPr>
@@ -7870,7 +7690,7 @@
       </p:pic>
       <p:sp>
         <p:nvSpPr>
-          <p:cNvPr id="7" name="Text 3"/>
+          <p:cNvPr id="5" name="Text 1"/>
           <p:cNvSpPr/>
           <p:nvPr/>
         </p:nvSpPr>
@@ -7909,7 +7729,7 @@
       </p:sp>
       <p:sp>
         <p:nvSpPr>
-          <p:cNvPr id="8" name="Shape 4"/>
+          <p:cNvPr id="6" name="Shape 2"/>
           <p:cNvSpPr/>
           <p:nvPr/>
         </p:nvSpPr>
@@ -7924,16 +7744,14 @@
             </a:avLst>
           </a:prstGeom>
           <a:solidFill>
-            <a:srgbClr val="24685C">
-              <a:alpha val="94000"/>
-            </a:srgbClr>
+            <a:srgbClr val="24685C"/>
           </a:solidFill>
           <a:ln/>
         </p:spPr>
       </p:sp>
       <p:sp>
         <p:nvSpPr>
-          <p:cNvPr id="9" name="Text 5"/>
+          <p:cNvPr id="7" name="Text 3"/>
           <p:cNvSpPr/>
           <p:nvPr/>
         </p:nvSpPr>
@@ -7972,7 +7790,7 @@
       </p:sp>
       <p:sp>
         <p:nvSpPr>
-          <p:cNvPr id="10" name="Text 6"/>
+          <p:cNvPr id="8" name="Text 4"/>
           <p:cNvSpPr/>
           <p:nvPr/>
         </p:nvSpPr>
@@ -8011,7 +7829,7 @@
       </p:sp>
       <p:sp>
         <p:nvSpPr>
-          <p:cNvPr id="11" name="Text 7"/>
+          <p:cNvPr id="9" name="Text 5"/>
           <p:cNvSpPr/>
           <p:nvPr/>
         </p:nvSpPr>
@@ -8053,7 +7871,7 @@
       </p:sp>
       <p:sp>
         <p:nvSpPr>
-          <p:cNvPr id="12" name="Text 8"/>
+          <p:cNvPr id="10" name="Text 6"/>
           <p:cNvSpPr/>
           <p:nvPr/>
         </p:nvSpPr>
@@ -8092,7 +7910,7 @@
       </p:sp>
       <p:sp>
         <p:nvSpPr>
-          <p:cNvPr id="13" name="Text 9"/>
+          <p:cNvPr id="11" name="Text 7"/>
           <p:cNvSpPr/>
           <p:nvPr/>
         </p:nvSpPr>
@@ -8131,7 +7949,7 @@
       </p:sp>
       <p:sp>
         <p:nvSpPr>
-          <p:cNvPr id="14" name="Shape 10"/>
+          <p:cNvPr id="12" name="Shape 8"/>
           <p:cNvSpPr/>
           <p:nvPr/>
         </p:nvSpPr>
@@ -8151,7 +7969,7 @@
       </p:sp>
       <p:sp>
         <p:nvSpPr>
-          <p:cNvPr id="15" name="Text 11"/>
+          <p:cNvPr id="13" name="Text 9"/>
           <p:cNvSpPr/>
           <p:nvPr/>
         </p:nvSpPr>
@@ -8210,7 +8028,7 @@
       </p:sp>
       <p:sp>
         <p:nvSpPr>
-          <p:cNvPr id="16" name="Shape 12"/>
+          <p:cNvPr id="14" name="Shape 10"/>
           <p:cNvSpPr/>
           <p:nvPr/>
         </p:nvSpPr>
@@ -8230,7 +8048,7 @@
       </p:sp>
       <p:sp>
         <p:nvSpPr>
-          <p:cNvPr id="17" name="Text 13"/>
+          <p:cNvPr id="15" name="Text 11"/>
           <p:cNvSpPr/>
           <p:nvPr/>
         </p:nvSpPr>
@@ -8289,7 +8107,7 @@
       </p:sp>
       <p:sp>
         <p:nvSpPr>
-          <p:cNvPr id="18" name="Shape 14"/>
+          <p:cNvPr id="16" name="Shape 12"/>
           <p:cNvSpPr/>
           <p:nvPr/>
         </p:nvSpPr>
@@ -8309,7 +8127,7 @@
       </p:sp>
       <p:sp>
         <p:nvSpPr>
-          <p:cNvPr id="19" name="Text 15"/>
+          <p:cNvPr id="17" name="Text 13"/>
           <p:cNvSpPr/>
           <p:nvPr/>
         </p:nvSpPr>
@@ -8368,7 +8186,7 @@
       </p:sp>
       <p:sp>
         <p:nvSpPr>
-          <p:cNvPr id="20" name="Shape 16"/>
+          <p:cNvPr id="18" name="Shape 14"/>
           <p:cNvSpPr/>
           <p:nvPr/>
         </p:nvSpPr>
@@ -8388,7 +8206,7 @@
       </p:sp>
       <p:sp>
         <p:nvSpPr>
-          <p:cNvPr id="21" name="Text 17"/>
+          <p:cNvPr id="19" name="Text 15"/>
           <p:cNvSpPr/>
           <p:nvPr/>
         </p:nvSpPr>
@@ -8447,7 +8265,7 @@
       </p:sp>
       <p:sp>
         <p:nvSpPr>
-          <p:cNvPr id="22" name="Shape 18"/>
+          <p:cNvPr id="20" name="Shape 16"/>
           <p:cNvSpPr/>
           <p:nvPr/>
         </p:nvSpPr>
@@ -8467,7 +8285,7 @@
       </p:sp>
       <p:sp>
         <p:nvSpPr>
-          <p:cNvPr id="23" name="Text 19"/>
+          <p:cNvPr id="21" name="Text 17"/>
           <p:cNvSpPr/>
           <p:nvPr/>
         </p:nvSpPr>
@@ -8526,7 +8344,7 @@
       </p:sp>
       <p:sp>
         <p:nvSpPr>
-          <p:cNvPr id="25" name="Text 20"/>
+          <p:cNvPr id="23" name="Text 18"/>
           <p:cNvSpPr/>
           <p:nvPr/>
         </p:nvSpPr>
@@ -8565,7 +8383,7 @@
       </p:sp>
       <p:sp>
         <p:nvSpPr>
-          <p:cNvPr id="26" name="Text 21"/>
+          <p:cNvPr id="24" name="Text 19"/>
           <p:cNvSpPr/>
           <p:nvPr/>
         </p:nvSpPr>
@@ -8636,7 +8454,7 @@
       </p:grpSpPr>
       <p:pic>
         <p:nvPicPr>
-          <p:cNvPr id="2" name="Image 0" descr="/tmp/claude-0/-home-user-spanwerk-datenschutz/aecddc76-056b-54e2-a906-9229bc8dda84/scratchpad/final/img_ptbs.jpg">    </p:cNvPr>
+          <p:cNvPr id="2" name="Image 0" descr="/tmp/claude-0/-home-user-spanwerk-datenschutz/aecddc76-056b-54e2-a906-9229bc8dda84/scratchpad/final/img_ptbs_panel.jpg">    </p:cNvPr>
           <p:cNvPicPr>
             <a:picLocks noChangeAspect="1"/>
           </p:cNvPicPr>
@@ -8665,50 +8483,6 @@
         </p:nvSpPr>
         <p:spPr>
           <a:xfrm>
-            <a:off x="0" y="0"/>
-            <a:ext cx="4206240" cy="6858000"/>
-          </a:xfrm>
-          <a:prstGeom prst="rect">
-            <a:avLst/>
-          </a:prstGeom>
-          <a:solidFill>
-            <a:srgbClr val="2C7A6B">
-              <a:alpha val="72000"/>
-            </a:srgbClr>
-          </a:solidFill>
-          <a:ln/>
-        </p:spPr>
-      </p:sp>
-      <p:sp>
-        <p:nvSpPr>
-          <p:cNvPr id="4" name="Shape 1"/>
-          <p:cNvSpPr/>
-          <p:nvPr/>
-        </p:nvSpPr>
-        <p:spPr>
-          <a:xfrm>
-            <a:off x="0" y="0"/>
-            <a:ext cx="4206240" cy="2651760"/>
-          </a:xfrm>
-          <a:prstGeom prst="rect">
-            <a:avLst/>
-          </a:prstGeom>
-          <a:solidFill>
-            <a:srgbClr val="2C7A6B">
-              <a:alpha val="92000"/>
-            </a:srgbClr>
-          </a:solidFill>
-          <a:ln/>
-        </p:spPr>
-      </p:sp>
-      <p:sp>
-        <p:nvSpPr>
-          <p:cNvPr id="5" name="Shape 2"/>
-          <p:cNvSpPr/>
-          <p:nvPr/>
-        </p:nvSpPr>
-        <p:spPr>
-          <a:xfrm>
             <a:off x="566928" y="566928"/>
             <a:ext cx="1051560" cy="1051560"/>
           </a:xfrm>
@@ -8723,7 +8497,7 @@
       </p:sp>
       <p:pic>
         <p:nvPicPr>
-          <p:cNvPr id="6" name="Image 1" descr="preencoded.png">    </p:cNvPr>
+          <p:cNvPr id="4" name="Image 1" descr="preencoded.png">    </p:cNvPr>
           <p:cNvPicPr>
             <a:picLocks noChangeAspect="1"/>
           </p:cNvPicPr>
@@ -8747,7 +8521,7 @@
       </p:pic>
       <p:sp>
         <p:nvSpPr>
-          <p:cNvPr id="7" name="Text 3"/>
+          <p:cNvPr id="5" name="Text 1"/>
           <p:cNvSpPr/>
           <p:nvPr/>
         </p:nvSpPr>
@@ -8786,7 +8560,7 @@
       </p:sp>
       <p:sp>
         <p:nvSpPr>
-          <p:cNvPr id="8" name="Shape 4"/>
+          <p:cNvPr id="6" name="Shape 2"/>
           <p:cNvSpPr/>
           <p:nvPr/>
         </p:nvSpPr>
@@ -8801,16 +8575,14 @@
             </a:avLst>
           </a:prstGeom>
           <a:solidFill>
-            <a:srgbClr val="24685C">
-              <a:alpha val="94000"/>
-            </a:srgbClr>
+            <a:srgbClr val="24685C"/>
           </a:solidFill>
           <a:ln/>
         </p:spPr>
       </p:sp>
       <p:sp>
         <p:nvSpPr>
-          <p:cNvPr id="9" name="Text 5"/>
+          <p:cNvPr id="7" name="Text 3"/>
           <p:cNvSpPr/>
           <p:nvPr/>
         </p:nvSpPr>
@@ -8849,7 +8621,7 @@
       </p:sp>
       <p:sp>
         <p:nvSpPr>
-          <p:cNvPr id="10" name="Text 6"/>
+          <p:cNvPr id="8" name="Text 4"/>
           <p:cNvSpPr/>
           <p:nvPr/>
         </p:nvSpPr>
@@ -8888,7 +8660,7 @@
       </p:sp>
       <p:sp>
         <p:nvSpPr>
-          <p:cNvPr id="11" name="Text 7"/>
+          <p:cNvPr id="9" name="Text 5"/>
           <p:cNvSpPr/>
           <p:nvPr/>
         </p:nvSpPr>
@@ -8930,7 +8702,7 @@
       </p:sp>
       <p:sp>
         <p:nvSpPr>
-          <p:cNvPr id="12" name="Text 8"/>
+          <p:cNvPr id="10" name="Text 6"/>
           <p:cNvSpPr/>
           <p:nvPr/>
         </p:nvSpPr>
@@ -8969,7 +8741,7 @@
       </p:sp>
       <p:sp>
         <p:nvSpPr>
-          <p:cNvPr id="13" name="Text 9"/>
+          <p:cNvPr id="11" name="Text 7"/>
           <p:cNvSpPr/>
           <p:nvPr/>
         </p:nvSpPr>
@@ -9008,7 +8780,7 @@
       </p:sp>
       <p:sp>
         <p:nvSpPr>
-          <p:cNvPr id="14" name="Shape 10"/>
+          <p:cNvPr id="12" name="Shape 8"/>
           <p:cNvSpPr/>
           <p:nvPr/>
         </p:nvSpPr>
@@ -9028,7 +8800,7 @@
       </p:sp>
       <p:sp>
         <p:nvSpPr>
-          <p:cNvPr id="15" name="Text 11"/>
+          <p:cNvPr id="13" name="Text 9"/>
           <p:cNvSpPr/>
           <p:nvPr/>
         </p:nvSpPr>
@@ -9087,7 +8859,7 @@
       </p:sp>
       <p:sp>
         <p:nvSpPr>
-          <p:cNvPr id="16" name="Shape 12"/>
+          <p:cNvPr id="14" name="Shape 10"/>
           <p:cNvSpPr/>
           <p:nvPr/>
         </p:nvSpPr>
@@ -9107,7 +8879,7 @@
       </p:sp>
       <p:sp>
         <p:nvSpPr>
-          <p:cNvPr id="17" name="Text 13"/>
+          <p:cNvPr id="15" name="Text 11"/>
           <p:cNvSpPr/>
           <p:nvPr/>
         </p:nvSpPr>
@@ -9166,7 +8938,7 @@
       </p:sp>
       <p:sp>
         <p:nvSpPr>
-          <p:cNvPr id="18" name="Shape 14"/>
+          <p:cNvPr id="16" name="Shape 12"/>
           <p:cNvSpPr/>
           <p:nvPr/>
         </p:nvSpPr>
@@ -9186,7 +8958,7 @@
       </p:sp>
       <p:sp>
         <p:nvSpPr>
-          <p:cNvPr id="19" name="Text 15"/>
+          <p:cNvPr id="17" name="Text 13"/>
           <p:cNvSpPr/>
           <p:nvPr/>
         </p:nvSpPr>
@@ -9245,7 +9017,7 @@
       </p:sp>
       <p:sp>
         <p:nvSpPr>
-          <p:cNvPr id="20" name="Shape 16"/>
+          <p:cNvPr id="18" name="Shape 14"/>
           <p:cNvSpPr/>
           <p:nvPr/>
         </p:nvSpPr>
@@ -9265,7 +9037,7 @@
       </p:sp>
       <p:sp>
         <p:nvSpPr>
-          <p:cNvPr id="21" name="Text 17"/>
+          <p:cNvPr id="19" name="Text 15"/>
           <p:cNvSpPr/>
           <p:nvPr/>
         </p:nvSpPr>
@@ -9324,7 +9096,7 @@
       </p:sp>
       <p:sp>
         <p:nvSpPr>
-          <p:cNvPr id="22" name="Shape 18"/>
+          <p:cNvPr id="20" name="Shape 16"/>
           <p:cNvSpPr/>
           <p:nvPr/>
         </p:nvSpPr>
@@ -9344,7 +9116,7 @@
       </p:sp>
       <p:sp>
         <p:nvSpPr>
-          <p:cNvPr id="23" name="Text 19"/>
+          <p:cNvPr id="21" name="Text 17"/>
           <p:cNvSpPr/>
           <p:nvPr/>
         </p:nvSpPr>
@@ -9403,7 +9175,7 @@
       </p:sp>
       <p:sp>
         <p:nvSpPr>
-          <p:cNvPr id="25" name="Text 20"/>
+          <p:cNvPr id="23" name="Text 18"/>
           <p:cNvSpPr/>
           <p:nvPr/>
         </p:nvSpPr>
@@ -9442,7 +9214,7 @@
       </p:sp>
       <p:sp>
         <p:nvSpPr>
-          <p:cNvPr id="26" name="Text 21"/>
+          <p:cNvPr id="24" name="Text 19"/>
           <p:cNvSpPr/>
           <p:nvPr/>
         </p:nvSpPr>
@@ -9513,7 +9285,7 @@
       </p:grpSpPr>
       <p:pic>
         <p:nvPicPr>
-          <p:cNvPr id="2" name="Image 0" descr="/tmp/claude-0/-home-user-spanwerk-datenschutz/aecddc76-056b-54e2-a906-9229bc8dda84/scratchpad/final/img_bipolar.jpg">    </p:cNvPr>
+          <p:cNvPr id="2" name="Image 0" descr="/tmp/claude-0/-home-user-spanwerk-datenschutz/aecddc76-056b-54e2-a906-9229bc8dda84/scratchpad/final/img_bipolar_panel.jpg">    </p:cNvPr>
           <p:cNvPicPr>
             <a:picLocks noChangeAspect="1"/>
           </p:cNvPicPr>
@@ -9542,50 +9314,6 @@
         </p:nvSpPr>
         <p:spPr>
           <a:xfrm>
-            <a:off x="0" y="0"/>
-            <a:ext cx="4206240" cy="6858000"/>
-          </a:xfrm>
-          <a:prstGeom prst="rect">
-            <a:avLst/>
-          </a:prstGeom>
-          <a:solidFill>
-            <a:srgbClr val="2C7A6B">
-              <a:alpha val="72000"/>
-            </a:srgbClr>
-          </a:solidFill>
-          <a:ln/>
-        </p:spPr>
-      </p:sp>
-      <p:sp>
-        <p:nvSpPr>
-          <p:cNvPr id="4" name="Shape 1"/>
-          <p:cNvSpPr/>
-          <p:nvPr/>
-        </p:nvSpPr>
-        <p:spPr>
-          <a:xfrm>
-            <a:off x="0" y="0"/>
-            <a:ext cx="4206240" cy="2651760"/>
-          </a:xfrm>
-          <a:prstGeom prst="rect">
-            <a:avLst/>
-          </a:prstGeom>
-          <a:solidFill>
-            <a:srgbClr val="2C7A6B">
-              <a:alpha val="92000"/>
-            </a:srgbClr>
-          </a:solidFill>
-          <a:ln/>
-        </p:spPr>
-      </p:sp>
-      <p:sp>
-        <p:nvSpPr>
-          <p:cNvPr id="5" name="Shape 2"/>
-          <p:cNvSpPr/>
-          <p:nvPr/>
-        </p:nvSpPr>
-        <p:spPr>
-          <a:xfrm>
             <a:off x="566928" y="566928"/>
             <a:ext cx="1051560" cy="1051560"/>
           </a:xfrm>
@@ -9600,7 +9328,7 @@
       </p:sp>
       <p:pic>
         <p:nvPicPr>
-          <p:cNvPr id="6" name="Image 1" descr="preencoded.png">    </p:cNvPr>
+          <p:cNvPr id="4" name="Image 1" descr="preencoded.png">    </p:cNvPr>
           <p:cNvPicPr>
             <a:picLocks noChangeAspect="1"/>
           </p:cNvPicPr>
@@ -9624,7 +9352,7 @@
       </p:pic>
       <p:sp>
         <p:nvSpPr>
-          <p:cNvPr id="7" name="Text 3"/>
+          <p:cNvPr id="5" name="Text 1"/>
           <p:cNvSpPr/>
           <p:nvPr/>
         </p:nvSpPr>
@@ -9663,7 +9391,7 @@
       </p:sp>
       <p:sp>
         <p:nvSpPr>
-          <p:cNvPr id="8" name="Shape 4"/>
+          <p:cNvPr id="6" name="Shape 2"/>
           <p:cNvSpPr/>
           <p:nvPr/>
         </p:nvSpPr>
@@ -9678,16 +9406,14 @@
             </a:avLst>
           </a:prstGeom>
           <a:solidFill>
-            <a:srgbClr val="24685C">
-              <a:alpha val="94000"/>
-            </a:srgbClr>
+            <a:srgbClr val="24685C"/>
           </a:solidFill>
           <a:ln/>
         </p:spPr>
       </p:sp>
       <p:sp>
         <p:nvSpPr>
-          <p:cNvPr id="9" name="Text 5"/>
+          <p:cNvPr id="7" name="Text 3"/>
           <p:cNvSpPr/>
           <p:nvPr/>
         </p:nvSpPr>
@@ -9726,7 +9452,7 @@
       </p:sp>
       <p:sp>
         <p:nvSpPr>
-          <p:cNvPr id="10" name="Text 6"/>
+          <p:cNvPr id="8" name="Text 4"/>
           <p:cNvSpPr/>
           <p:nvPr/>
         </p:nvSpPr>
@@ -9765,7 +9491,7 @@
       </p:sp>
       <p:sp>
         <p:nvSpPr>
-          <p:cNvPr id="11" name="Text 7"/>
+          <p:cNvPr id="9" name="Text 5"/>
           <p:cNvSpPr/>
           <p:nvPr/>
         </p:nvSpPr>
@@ -9807,7 +9533,7 @@
       </p:sp>
       <p:sp>
         <p:nvSpPr>
-          <p:cNvPr id="12" name="Text 8"/>
+          <p:cNvPr id="10" name="Text 6"/>
           <p:cNvSpPr/>
           <p:nvPr/>
         </p:nvSpPr>
@@ -9846,7 +9572,7 @@
       </p:sp>
       <p:sp>
         <p:nvSpPr>
-          <p:cNvPr id="13" name="Text 9"/>
+          <p:cNvPr id="11" name="Text 7"/>
           <p:cNvSpPr/>
           <p:nvPr/>
         </p:nvSpPr>
@@ -9885,7 +9611,7 @@
       </p:sp>
       <p:sp>
         <p:nvSpPr>
-          <p:cNvPr id="14" name="Shape 10"/>
+          <p:cNvPr id="12" name="Shape 8"/>
           <p:cNvSpPr/>
           <p:nvPr/>
         </p:nvSpPr>
@@ -9905,7 +9631,7 @@
       </p:sp>
       <p:sp>
         <p:nvSpPr>
-          <p:cNvPr id="15" name="Text 11"/>
+          <p:cNvPr id="13" name="Text 9"/>
           <p:cNvSpPr/>
           <p:nvPr/>
         </p:nvSpPr>
@@ -9964,7 +9690,7 @@
       </p:sp>
       <p:sp>
         <p:nvSpPr>
-          <p:cNvPr id="16" name="Shape 12"/>
+          <p:cNvPr id="14" name="Shape 10"/>
           <p:cNvSpPr/>
           <p:nvPr/>
         </p:nvSpPr>
@@ -9984,7 +9710,7 @@
       </p:sp>
       <p:sp>
         <p:nvSpPr>
-          <p:cNvPr id="17" name="Text 13"/>
+          <p:cNvPr id="15" name="Text 11"/>
           <p:cNvSpPr/>
           <p:nvPr/>
         </p:nvSpPr>
@@ -10043,7 +9769,7 @@
       </p:sp>
       <p:sp>
         <p:nvSpPr>
-          <p:cNvPr id="18" name="Shape 14"/>
+          <p:cNvPr id="16" name="Shape 12"/>
           <p:cNvSpPr/>
           <p:nvPr/>
         </p:nvSpPr>
@@ -10063,7 +9789,7 @@
       </p:sp>
       <p:sp>
         <p:nvSpPr>
-          <p:cNvPr id="19" name="Text 15"/>
+          <p:cNvPr id="17" name="Text 13"/>
           <p:cNvSpPr/>
           <p:nvPr/>
         </p:nvSpPr>
@@ -10122,7 +9848,7 @@
       </p:sp>
       <p:sp>
         <p:nvSpPr>
-          <p:cNvPr id="20" name="Shape 16"/>
+          <p:cNvPr id="18" name="Shape 14"/>
           <p:cNvSpPr/>
           <p:nvPr/>
         </p:nvSpPr>
@@ -10142,7 +9868,7 @@
       </p:sp>
       <p:sp>
         <p:nvSpPr>
-          <p:cNvPr id="21" name="Text 17"/>
+          <p:cNvPr id="19" name="Text 15"/>
           <p:cNvSpPr/>
           <p:nvPr/>
         </p:nvSpPr>
@@ -10201,7 +9927,7 @@
       </p:sp>
       <p:sp>
         <p:nvSpPr>
-          <p:cNvPr id="22" name="Shape 18"/>
+          <p:cNvPr id="20" name="Shape 16"/>
           <p:cNvSpPr/>
           <p:nvPr/>
         </p:nvSpPr>
@@ -10221,7 +9947,7 @@
       </p:sp>
       <p:sp>
         <p:nvSpPr>
-          <p:cNvPr id="23" name="Text 19"/>
+          <p:cNvPr id="21" name="Text 17"/>
           <p:cNvSpPr/>
           <p:nvPr/>
         </p:nvSpPr>
@@ -10280,7 +10006,7 @@
       </p:sp>
       <p:sp>
         <p:nvSpPr>
-          <p:cNvPr id="25" name="Text 20"/>
+          <p:cNvPr id="23" name="Text 18"/>
           <p:cNvSpPr/>
           <p:nvPr/>
         </p:nvSpPr>
@@ -10319,7 +10045,7 @@
       </p:sp>
       <p:sp>
         <p:nvSpPr>
-          <p:cNvPr id="26" name="Text 21"/>
+          <p:cNvPr id="24" name="Text 19"/>
           <p:cNvSpPr/>
           <p:nvPr/>
         </p:nvSpPr>
@@ -10383,7 +10109,7 @@
       </p:grpSpPr>
       <p:pic>
         <p:nvPicPr>
-          <p:cNvPr id="2" name="Image 0" descr="/tmp/claude-0/-home-user-spanwerk-datenschutz/aecddc76-056b-54e2-a906-9229bc8dda84/scratchpad/final/bg_natur.jpg">    </p:cNvPr>
+          <p:cNvPr id="2" name="Image 0" descr="/tmp/claude-0/-home-user-spanwerk-datenschutz/aecddc76-056b-54e2-a906-9229bc8dda84/scratchpad/final/bg_natur_dark.jpg">    </p:cNvPr>
           <p:cNvPicPr>
             <a:picLocks noChangeAspect="1"/>
           </p:cNvPicPr>
@@ -10406,51 +10132,7 @@
       </p:pic>
       <p:sp>
         <p:nvSpPr>
-          <p:cNvPr id="3" name="Shape 0"/>
-          <p:cNvSpPr/>
-          <p:nvPr/>
-        </p:nvSpPr>
-        <p:spPr>
-          <a:xfrm>
-            <a:off x="0" y="0"/>
-            <a:ext cx="12191695" cy="6858000"/>
-          </a:xfrm>
-          <a:prstGeom prst="rect">
-            <a:avLst/>
-          </a:prstGeom>
-          <a:solidFill>
-            <a:srgbClr val="24685C">
-              <a:alpha val="80000"/>
-            </a:srgbClr>
-          </a:solidFill>
-          <a:ln/>
-        </p:spPr>
-      </p:sp>
-      <p:sp>
-        <p:nvSpPr>
-          <p:cNvPr id="4" name="Shape 1"/>
-          <p:cNvSpPr/>
-          <p:nvPr/>
-        </p:nvSpPr>
-        <p:spPr>
-          <a:xfrm>
-            <a:off x="0" y="0"/>
-            <a:ext cx="12191695" cy="6858000"/>
-          </a:xfrm>
-          <a:prstGeom prst="rect">
-            <a:avLst/>
-          </a:prstGeom>
-          <a:solidFill>
-            <a:srgbClr val="24685C">
-              <a:alpha val="86000"/>
-            </a:srgbClr>
-          </a:solidFill>
-          <a:ln/>
-        </p:spPr>
-      </p:sp>
-      <p:sp>
-        <p:nvSpPr>
-          <p:cNvPr id="5" name="Text 2"/>
+          <p:cNvPr id="3" name="Text 0"/>
           <p:cNvSpPr/>
           <p:nvPr/>
         </p:nvSpPr>
@@ -10489,7 +10171,7 @@
       </p:sp>
       <p:sp>
         <p:nvSpPr>
-          <p:cNvPr id="6" name="Text 3"/>
+          <p:cNvPr id="4" name="Text 1"/>
           <p:cNvSpPr/>
           <p:nvPr/>
         </p:nvSpPr>
@@ -10528,7 +10210,7 @@
       </p:sp>
       <p:sp>
         <p:nvSpPr>
-          <p:cNvPr id="7" name="Text 4"/>
+          <p:cNvPr id="5" name="Text 2"/>
           <p:cNvSpPr/>
           <p:nvPr/>
         </p:nvSpPr>
@@ -10570,7 +10252,7 @@
       </p:sp>
       <p:sp>
         <p:nvSpPr>
-          <p:cNvPr id="9" name="Text 5"/>
+          <p:cNvPr id="7" name="Text 3"/>
           <p:cNvSpPr/>
           <p:nvPr/>
         </p:nvSpPr>
@@ -10609,7 +10291,7 @@
       </p:sp>
       <p:sp>
         <p:nvSpPr>
-          <p:cNvPr id="10" name="Text 6"/>
+          <p:cNvPr id="8" name="Text 4"/>
           <p:cNvSpPr/>
           <p:nvPr/>
         </p:nvSpPr>
@@ -11154,7 +10836,7 @@
       </p:grpSpPr>
       <p:pic>
         <p:nvPicPr>
-          <p:cNvPr id="2" name="Image 0" descr="/tmp/claude-0/-home-user-spanwerk-datenschutz/aecddc76-056b-54e2-a906-9229bc8dda84/scratchpad/final/bg_natur.jpg">    </p:cNvPr>
+          <p:cNvPr id="2" name="Image 0" descr="/tmp/claude-0/-home-user-spanwerk-datenschutz/aecddc76-056b-54e2-a906-9229bc8dda84/scratchpad/final/bg_natur_dark.jpg">    </p:cNvPr>
           <p:cNvPicPr>
             <a:picLocks noChangeAspect="1"/>
           </p:cNvPicPr>
@@ -11177,29 +10859,7 @@
       </p:pic>
       <p:sp>
         <p:nvSpPr>
-          <p:cNvPr id="3" name="Shape 0"/>
-          <p:cNvSpPr/>
-          <p:nvPr/>
-        </p:nvSpPr>
-        <p:spPr>
-          <a:xfrm>
-            <a:off x="0" y="0"/>
-            <a:ext cx="12191695" cy="6858000"/>
-          </a:xfrm>
-          <a:prstGeom prst="rect">
-            <a:avLst/>
-          </a:prstGeom>
-          <a:solidFill>
-            <a:srgbClr val="24685C">
-              <a:alpha val="78000"/>
-            </a:srgbClr>
-          </a:solidFill>
-          <a:ln/>
-        </p:spPr>
-      </p:sp>
-      <p:sp>
-        <p:nvSpPr>
-          <p:cNvPr id="4" name="Text 1"/>
+          <p:cNvPr id="3" name="Text 0"/>
           <p:cNvSpPr/>
           <p:nvPr/>
         </p:nvSpPr>
@@ -11238,7 +10898,7 @@
       </p:sp>
       <p:sp>
         <p:nvSpPr>
-          <p:cNvPr id="5" name="Text 2"/>
+          <p:cNvPr id="4" name="Text 1"/>
           <p:cNvSpPr/>
           <p:nvPr/>
         </p:nvSpPr>
@@ -11277,7 +10937,7 @@
       </p:sp>
       <p:sp>
         <p:nvSpPr>
-          <p:cNvPr id="6" name="Shape 3"/>
+          <p:cNvPr id="5" name="Shape 2"/>
           <p:cNvSpPr/>
           <p:nvPr/>
         </p:nvSpPr>
@@ -11297,7 +10957,7 @@
       </p:sp>
       <p:sp>
         <p:nvSpPr>
-          <p:cNvPr id="7" name="Text 4"/>
+          <p:cNvPr id="6" name="Text 3"/>
           <p:cNvSpPr/>
           <p:nvPr/>
         </p:nvSpPr>
@@ -11336,7 +10996,7 @@
       </p:sp>
       <p:sp>
         <p:nvSpPr>
-          <p:cNvPr id="8" name="Shape 5"/>
+          <p:cNvPr id="7" name="Shape 4"/>
           <p:cNvSpPr/>
           <p:nvPr/>
         </p:nvSpPr>
@@ -11356,7 +11016,7 @@
       </p:sp>
       <p:sp>
         <p:nvSpPr>
-          <p:cNvPr id="9" name="Text 6"/>
+          <p:cNvPr id="8" name="Text 5"/>
           <p:cNvSpPr/>
           <p:nvPr/>
         </p:nvSpPr>
@@ -11395,7 +11055,7 @@
       </p:sp>
       <p:sp>
         <p:nvSpPr>
-          <p:cNvPr id="10" name="Shape 7"/>
+          <p:cNvPr id="9" name="Shape 6"/>
           <p:cNvSpPr/>
           <p:nvPr/>
         </p:nvSpPr>
@@ -11408,9 +11068,7 @@
             <a:avLst/>
           </a:prstGeom>
           <a:solidFill>
-            <a:srgbClr val="24685C">
-              <a:alpha val="88000"/>
-            </a:srgbClr>
+            <a:srgbClr val="24685C"/>
           </a:solidFill>
           <a:ln w="12700">
             <a:solidFill>
@@ -11422,7 +11080,7 @@
       </p:sp>
       <p:sp>
         <p:nvSpPr>
-          <p:cNvPr id="11" name="Text 8"/>
+          <p:cNvPr id="10" name="Text 7"/>
           <p:cNvSpPr/>
           <p:nvPr/>
         </p:nvSpPr>
@@ -11461,7 +11119,7 @@
       </p:sp>
       <p:sp>
         <p:nvSpPr>
-          <p:cNvPr id="12" name="Text 9"/>
+          <p:cNvPr id="11" name="Text 8"/>
           <p:cNvSpPr/>
           <p:nvPr/>
         </p:nvSpPr>
@@ -11500,7 +11158,7 @@
       </p:sp>
       <p:sp>
         <p:nvSpPr>
-          <p:cNvPr id="13" name="Text 10"/>
+          <p:cNvPr id="12" name="Text 9"/>
           <p:cNvSpPr/>
           <p:nvPr/>
         </p:nvSpPr>
@@ -11539,7 +11197,7 @@
       </p:sp>
       <p:sp>
         <p:nvSpPr>
-          <p:cNvPr id="14" name="Text 11"/>
+          <p:cNvPr id="13" name="Text 10"/>
           <p:cNvSpPr/>
           <p:nvPr/>
         </p:nvSpPr>
@@ -11578,7 +11236,7 @@
       </p:sp>
       <p:sp>
         <p:nvSpPr>
-          <p:cNvPr id="15" name="Text 12"/>
+          <p:cNvPr id="14" name="Text 11"/>
           <p:cNvSpPr/>
           <p:nvPr/>
         </p:nvSpPr>
@@ -11617,7 +11275,7 @@
       </p:sp>
       <p:sp>
         <p:nvSpPr>
-          <p:cNvPr id="16" name="Text 13"/>
+          <p:cNvPr id="15" name="Text 12"/>
           <p:cNvSpPr/>
           <p:nvPr/>
         </p:nvSpPr>
@@ -11656,7 +11314,7 @@
       </p:sp>
       <p:sp>
         <p:nvSpPr>
-          <p:cNvPr id="17" name="Text 14"/>
+          <p:cNvPr id="16" name="Text 13"/>
           <p:cNvSpPr/>
           <p:nvPr/>
         </p:nvSpPr>
@@ -11695,7 +11353,7 @@
       </p:sp>
       <p:sp>
         <p:nvSpPr>
-          <p:cNvPr id="19" name="Text 15"/>
+          <p:cNvPr id="18" name="Text 14"/>
           <p:cNvSpPr/>
           <p:nvPr/>
         </p:nvSpPr>
@@ -11734,7 +11392,7 @@
       </p:sp>
       <p:sp>
         <p:nvSpPr>
-          <p:cNvPr id="20" name="Text 16"/>
+          <p:cNvPr id="19" name="Text 15"/>
           <p:cNvSpPr/>
           <p:nvPr/>
         </p:nvSpPr>
@@ -12426,9 +12084,7 @@
             <a:avLst/>
           </a:prstGeom>
           <a:solidFill>
-            <a:srgbClr val="24685C">
-              <a:alpha val="88000"/>
-            </a:srgbClr>
+            <a:srgbClr val="24685C"/>
           </a:solidFill>
           <a:ln/>
         </p:spPr>
@@ -14509,7 +14165,7 @@
       </p:grpSpPr>
       <p:pic>
         <p:nvPicPr>
-          <p:cNvPr id="2" name="Image 0" descr="/tmp/claude-0/-home-user-spanwerk-datenschutz/aecddc76-056b-54e2-a906-9229bc8dda84/scratchpad/final/img_angst.jpg">    </p:cNvPr>
+          <p:cNvPr id="2" name="Image 0" descr="/tmp/claude-0/-home-user-spanwerk-datenschutz/aecddc76-056b-54e2-a906-9229bc8dda84/scratchpad/final/img_angst_dark.jpg">    </p:cNvPr>
           <p:cNvPicPr>
             <a:picLocks noChangeAspect="1"/>
           </p:cNvPicPr>
@@ -14532,51 +14188,7 @@
       </p:pic>
       <p:sp>
         <p:nvSpPr>
-          <p:cNvPr id="3" name="Shape 0"/>
-          <p:cNvSpPr/>
-          <p:nvPr/>
-        </p:nvSpPr>
-        <p:spPr>
-          <a:xfrm>
-            <a:off x="0" y="0"/>
-            <a:ext cx="12191695" cy="6858000"/>
-          </a:xfrm>
-          <a:prstGeom prst="rect">
-            <a:avLst/>
-          </a:prstGeom>
-          <a:solidFill>
-            <a:srgbClr val="24685C">
-              <a:alpha val="80000"/>
-            </a:srgbClr>
-          </a:solidFill>
-          <a:ln/>
-        </p:spPr>
-      </p:sp>
-      <p:sp>
-        <p:nvSpPr>
-          <p:cNvPr id="4" name="Shape 1"/>
-          <p:cNvSpPr/>
-          <p:nvPr/>
-        </p:nvSpPr>
-        <p:spPr>
-          <a:xfrm>
-            <a:off x="0" y="0"/>
-            <a:ext cx="12191695" cy="6858000"/>
-          </a:xfrm>
-          <a:prstGeom prst="rect">
-            <a:avLst/>
-          </a:prstGeom>
-          <a:solidFill>
-            <a:srgbClr val="24685C">
-              <a:alpha val="88000"/>
-            </a:srgbClr>
-          </a:solidFill>
-          <a:ln/>
-        </p:spPr>
-      </p:sp>
-      <p:sp>
-        <p:nvSpPr>
-          <p:cNvPr id="5" name="Text 2"/>
+          <p:cNvPr id="3" name="Text 0"/>
           <p:cNvSpPr/>
           <p:nvPr/>
         </p:nvSpPr>
@@ -14615,7 +14227,7 @@
       </p:sp>
       <p:sp>
         <p:nvSpPr>
-          <p:cNvPr id="6" name="Text 3"/>
+          <p:cNvPr id="4" name="Text 1"/>
           <p:cNvSpPr/>
           <p:nvPr/>
         </p:nvSpPr>
@@ -14654,7 +14266,7 @@
       </p:sp>
       <p:sp>
         <p:nvSpPr>
-          <p:cNvPr id="7" name="Shape 4"/>
+          <p:cNvPr id="5" name="Shape 2"/>
           <p:cNvSpPr/>
           <p:nvPr/>
         </p:nvSpPr>
@@ -14669,16 +14281,14 @@
             </a:avLst>
           </a:prstGeom>
           <a:solidFill>
-            <a:srgbClr val="FFFFFF">
-              <a:alpha val="92000"/>
-            </a:srgbClr>
+            <a:srgbClr val="FFFFFF"/>
           </a:solidFill>
           <a:ln/>
         </p:spPr>
       </p:sp>
       <p:sp>
         <p:nvSpPr>
-          <p:cNvPr id="8" name="Shape 5"/>
+          <p:cNvPr id="6" name="Shape 3"/>
           <p:cNvSpPr/>
           <p:nvPr/>
         </p:nvSpPr>
@@ -14698,7 +14308,7 @@
       </p:sp>
       <p:pic>
         <p:nvPicPr>
-          <p:cNvPr id="9" name="Image 1" descr="preencoded.png">    </p:cNvPr>
+          <p:cNvPr id="7" name="Image 1" descr="preencoded.png">    </p:cNvPr>
           <p:cNvPicPr>
             <a:picLocks noChangeAspect="1"/>
           </p:cNvPicPr>
@@ -14722,7 +14332,7 @@
       </p:pic>
       <p:sp>
         <p:nvSpPr>
-          <p:cNvPr id="10" name="Text 6"/>
+          <p:cNvPr id="8" name="Text 4"/>
           <p:cNvSpPr/>
           <p:nvPr/>
         </p:nvSpPr>
@@ -14761,7 +14371,7 @@
       </p:sp>
       <p:sp>
         <p:nvSpPr>
-          <p:cNvPr id="11" name="Text 7"/>
+          <p:cNvPr id="9" name="Text 5"/>
           <p:cNvSpPr/>
           <p:nvPr/>
         </p:nvSpPr>
@@ -14800,7 +14410,7 @@
       </p:sp>
       <p:sp>
         <p:nvSpPr>
-          <p:cNvPr id="12" name="Shape 8"/>
+          <p:cNvPr id="10" name="Shape 6"/>
           <p:cNvSpPr/>
           <p:nvPr/>
         </p:nvSpPr>
@@ -14815,16 +14425,14 @@
             </a:avLst>
           </a:prstGeom>
           <a:solidFill>
-            <a:srgbClr val="FFFFFF">
-              <a:alpha val="92000"/>
-            </a:srgbClr>
+            <a:srgbClr val="FFFFFF"/>
           </a:solidFill>
           <a:ln/>
         </p:spPr>
       </p:sp>
       <p:sp>
         <p:nvSpPr>
-          <p:cNvPr id="13" name="Shape 9"/>
+          <p:cNvPr id="11" name="Shape 7"/>
           <p:cNvSpPr/>
           <p:nvPr/>
         </p:nvSpPr>
@@ -14844,7 +14452,7 @@
       </p:sp>
       <p:pic>
         <p:nvPicPr>
-          <p:cNvPr id="14" name="Image 2" descr="preencoded.png">    </p:cNvPr>
+          <p:cNvPr id="12" name="Image 2" descr="preencoded.png">    </p:cNvPr>
           <p:cNvPicPr>
             <a:picLocks noChangeAspect="1"/>
           </p:cNvPicPr>
@@ -14868,7 +14476,7 @@
       </p:pic>
       <p:sp>
         <p:nvSpPr>
-          <p:cNvPr id="15" name="Text 10"/>
+          <p:cNvPr id="13" name="Text 8"/>
           <p:cNvSpPr/>
           <p:nvPr/>
         </p:nvSpPr>
@@ -14907,7 +14515,7 @@
       </p:sp>
       <p:sp>
         <p:nvSpPr>
-          <p:cNvPr id="16" name="Text 11"/>
+          <p:cNvPr id="14" name="Text 9"/>
           <p:cNvSpPr/>
           <p:nvPr/>
         </p:nvSpPr>
@@ -14946,7 +14554,7 @@
       </p:sp>
       <p:sp>
         <p:nvSpPr>
-          <p:cNvPr id="17" name="Shape 12"/>
+          <p:cNvPr id="15" name="Shape 10"/>
           <p:cNvSpPr/>
           <p:nvPr/>
         </p:nvSpPr>
@@ -14961,16 +14569,14 @@
             </a:avLst>
           </a:prstGeom>
           <a:solidFill>
-            <a:srgbClr val="FFFFFF">
-              <a:alpha val="92000"/>
-            </a:srgbClr>
+            <a:srgbClr val="FFFFFF"/>
           </a:solidFill>
           <a:ln/>
         </p:spPr>
       </p:sp>
       <p:sp>
         <p:nvSpPr>
-          <p:cNvPr id="18" name="Shape 13"/>
+          <p:cNvPr id="16" name="Shape 11"/>
           <p:cNvSpPr/>
           <p:nvPr/>
         </p:nvSpPr>
@@ -14990,7 +14596,7 @@
       </p:sp>
       <p:pic>
         <p:nvPicPr>
-          <p:cNvPr id="19" name="Image 3" descr="preencoded.png">    </p:cNvPr>
+          <p:cNvPr id="17" name="Image 3" descr="preencoded.png">    </p:cNvPr>
           <p:cNvPicPr>
             <a:picLocks noChangeAspect="1"/>
           </p:cNvPicPr>
@@ -15014,7 +14620,7 @@
       </p:pic>
       <p:sp>
         <p:nvSpPr>
-          <p:cNvPr id="20" name="Text 14"/>
+          <p:cNvPr id="18" name="Text 12"/>
           <p:cNvSpPr/>
           <p:nvPr/>
         </p:nvSpPr>
@@ -15053,7 +14659,7 @@
       </p:sp>
       <p:sp>
         <p:nvSpPr>
-          <p:cNvPr id="21" name="Text 15"/>
+          <p:cNvPr id="19" name="Text 13"/>
           <p:cNvSpPr/>
           <p:nvPr/>
         </p:nvSpPr>
@@ -15092,7 +14698,7 @@
       </p:sp>
       <p:sp>
         <p:nvSpPr>
-          <p:cNvPr id="22" name="Shape 16"/>
+          <p:cNvPr id="20" name="Shape 14"/>
           <p:cNvSpPr/>
           <p:nvPr/>
         </p:nvSpPr>
@@ -15107,16 +14713,14 @@
             </a:avLst>
           </a:prstGeom>
           <a:solidFill>
-            <a:srgbClr val="FFFFFF">
-              <a:alpha val="92000"/>
-            </a:srgbClr>
+            <a:srgbClr val="FFFFFF"/>
           </a:solidFill>
           <a:ln/>
         </p:spPr>
       </p:sp>
       <p:sp>
         <p:nvSpPr>
-          <p:cNvPr id="23" name="Shape 17"/>
+          <p:cNvPr id="21" name="Shape 15"/>
           <p:cNvSpPr/>
           <p:nvPr/>
         </p:nvSpPr>
@@ -15136,7 +14740,7 @@
       </p:sp>
       <p:pic>
         <p:nvPicPr>
-          <p:cNvPr id="24" name="Image 4" descr="preencoded.png">    </p:cNvPr>
+          <p:cNvPr id="22" name="Image 4" descr="preencoded.png">    </p:cNvPr>
           <p:cNvPicPr>
             <a:picLocks noChangeAspect="1"/>
           </p:cNvPicPr>
@@ -15160,7 +14764,7 @@
       </p:pic>
       <p:sp>
         <p:nvSpPr>
-          <p:cNvPr id="25" name="Text 18"/>
+          <p:cNvPr id="23" name="Text 16"/>
           <p:cNvSpPr/>
           <p:nvPr/>
         </p:nvSpPr>
@@ -15199,7 +14803,7 @@
       </p:sp>
       <p:sp>
         <p:nvSpPr>
-          <p:cNvPr id="26" name="Text 19"/>
+          <p:cNvPr id="24" name="Text 17"/>
           <p:cNvSpPr/>
           <p:nvPr/>
         </p:nvSpPr>
@@ -15238,7 +14842,7 @@
       </p:sp>
       <p:sp>
         <p:nvSpPr>
-          <p:cNvPr id="27" name="Text 20"/>
+          <p:cNvPr id="25" name="Text 18"/>
           <p:cNvSpPr/>
           <p:nvPr/>
         </p:nvSpPr>
@@ -15277,7 +14881,7 @@
       </p:sp>
       <p:sp>
         <p:nvSpPr>
-          <p:cNvPr id="29" name="Text 21"/>
+          <p:cNvPr id="27" name="Text 19"/>
           <p:cNvSpPr/>
           <p:nvPr/>
         </p:nvSpPr>
@@ -15316,7 +14920,7 @@
       </p:sp>
       <p:sp>
         <p:nvSpPr>
-          <p:cNvPr id="30" name="Text 22"/>
+          <p:cNvPr id="28" name="Text 20"/>
           <p:cNvSpPr/>
           <p:nvPr/>
         </p:nvSpPr>
@@ -16231,7 +15835,7 @@
       </p:grpSpPr>
       <p:pic>
         <p:nvPicPr>
-          <p:cNvPr id="2" name="Image 0" descr="/tmp/claude-0/-home-user-spanwerk-datenschutz/aecddc76-056b-54e2-a906-9229bc8dda84/scratchpad/final/bg_natur.jpg">    </p:cNvPr>
+          <p:cNvPr id="2" name="Image 0" descr="/tmp/claude-0/-home-user-spanwerk-datenschutz/aecddc76-056b-54e2-a906-9229bc8dda84/scratchpad/final/bg_natur_dark.jpg">    </p:cNvPr>
           <p:cNvPicPr>
             <a:picLocks noChangeAspect="1"/>
           </p:cNvPicPr>
@@ -16260,50 +15864,6 @@
         </p:nvSpPr>
         <p:spPr>
           <a:xfrm>
-            <a:off x="0" y="0"/>
-            <a:ext cx="12191695" cy="6858000"/>
-          </a:xfrm>
-          <a:prstGeom prst="rect">
-            <a:avLst/>
-          </a:prstGeom>
-          <a:solidFill>
-            <a:srgbClr val="24685C">
-              <a:alpha val="88000"/>
-            </a:srgbClr>
-          </a:solidFill>
-          <a:ln/>
-        </p:spPr>
-      </p:sp>
-      <p:sp>
-        <p:nvSpPr>
-          <p:cNvPr id="4" name="Shape 1"/>
-          <p:cNvSpPr/>
-          <p:nvPr/>
-        </p:nvSpPr>
-        <p:spPr>
-          <a:xfrm>
-            <a:off x="0" y="0"/>
-            <a:ext cx="4114800" cy="6858000"/>
-          </a:xfrm>
-          <a:prstGeom prst="rect">
-            <a:avLst/>
-          </a:prstGeom>
-          <a:solidFill>
-            <a:srgbClr val="24685C">
-              <a:alpha val="92000"/>
-            </a:srgbClr>
-          </a:solidFill>
-          <a:ln/>
-        </p:spPr>
-      </p:sp>
-      <p:sp>
-        <p:nvSpPr>
-          <p:cNvPr id="5" name="Shape 2"/>
-          <p:cNvSpPr/>
-          <p:nvPr/>
-        </p:nvSpPr>
-        <p:spPr>
-          <a:xfrm>
             <a:off x="1371600" y="1097280"/>
             <a:ext cx="1371600" cy="1371600"/>
           </a:xfrm>
@@ -16318,7 +15878,7 @@
       </p:sp>
       <p:pic>
         <p:nvPicPr>
-          <p:cNvPr id="6" name="Image 1" descr="preencoded.png">    </p:cNvPr>
+          <p:cNvPr id="4" name="Image 1" descr="preencoded.png">    </p:cNvPr>
           <p:cNvPicPr>
             <a:picLocks noChangeAspect="1"/>
           </p:cNvPicPr>
@@ -16342,7 +15902,7 @@
       </p:pic>
       <p:sp>
         <p:nvSpPr>
-          <p:cNvPr id="7" name="Text 3"/>
+          <p:cNvPr id="5" name="Text 1"/>
           <p:cNvSpPr/>
           <p:nvPr/>
         </p:nvSpPr>
@@ -16381,7 +15941,7 @@
       </p:sp>
       <p:sp>
         <p:nvSpPr>
-          <p:cNvPr id="8" name="Text 4"/>
+          <p:cNvPr id="6" name="Text 2"/>
           <p:cNvSpPr/>
           <p:nvPr/>
         </p:nvSpPr>
@@ -16420,7 +15980,7 @@
       </p:sp>
       <p:sp>
         <p:nvSpPr>
-          <p:cNvPr id="9" name="Shape 5"/>
+          <p:cNvPr id="7" name="Shape 3"/>
           <p:cNvSpPr/>
           <p:nvPr/>
         </p:nvSpPr>
@@ -16442,7 +16002,7 @@
       </p:sp>
       <p:sp>
         <p:nvSpPr>
-          <p:cNvPr id="10" name="Text 6"/>
+          <p:cNvPr id="8" name="Text 4"/>
           <p:cNvSpPr/>
           <p:nvPr/>
         </p:nvSpPr>
@@ -16481,7 +16041,7 @@
       </p:sp>
       <p:sp>
         <p:nvSpPr>
-          <p:cNvPr id="11" name="Text 7"/>
+          <p:cNvPr id="9" name="Text 5"/>
           <p:cNvSpPr/>
           <p:nvPr/>
         </p:nvSpPr>
@@ -16520,7 +16080,7 @@
       </p:sp>
       <p:sp>
         <p:nvSpPr>
-          <p:cNvPr id="12" name="Shape 8"/>
+          <p:cNvPr id="10" name="Shape 6"/>
           <p:cNvSpPr/>
           <p:nvPr/>
         </p:nvSpPr>
@@ -16540,7 +16100,7 @@
       </p:sp>
       <p:sp>
         <p:nvSpPr>
-          <p:cNvPr id="13" name="Text 9"/>
+          <p:cNvPr id="11" name="Text 7"/>
           <p:cNvSpPr/>
           <p:nvPr/>
         </p:nvSpPr>
@@ -16579,7 +16139,7 @@
       </p:sp>
       <p:sp>
         <p:nvSpPr>
-          <p:cNvPr id="14" name="Text 10"/>
+          <p:cNvPr id="12" name="Text 8"/>
           <p:cNvSpPr/>
           <p:nvPr/>
         </p:nvSpPr>
@@ -16621,7 +16181,7 @@
       </p:sp>
       <p:sp>
         <p:nvSpPr>
-          <p:cNvPr id="15" name="Shape 11"/>
+          <p:cNvPr id="13" name="Shape 9"/>
           <p:cNvSpPr/>
           <p:nvPr/>
         </p:nvSpPr>
@@ -16641,7 +16201,7 @@
       </p:sp>
       <p:sp>
         <p:nvSpPr>
-          <p:cNvPr id="16" name="Text 12"/>
+          <p:cNvPr id="14" name="Text 10"/>
           <p:cNvSpPr/>
           <p:nvPr/>
         </p:nvSpPr>
@@ -16680,7 +16240,7 @@
       </p:sp>
       <p:sp>
         <p:nvSpPr>
-          <p:cNvPr id="17" name="Text 13"/>
+          <p:cNvPr id="15" name="Text 11"/>
           <p:cNvSpPr/>
           <p:nvPr/>
         </p:nvSpPr>
@@ -16722,7 +16282,7 @@
       </p:sp>
       <p:sp>
         <p:nvSpPr>
-          <p:cNvPr id="18" name="Shape 14"/>
+          <p:cNvPr id="16" name="Shape 12"/>
           <p:cNvSpPr/>
           <p:nvPr/>
         </p:nvSpPr>
@@ -16742,7 +16302,7 @@
       </p:sp>
       <p:sp>
         <p:nvSpPr>
-          <p:cNvPr id="19" name="Text 15"/>
+          <p:cNvPr id="17" name="Text 13"/>
           <p:cNvSpPr/>
           <p:nvPr/>
         </p:nvSpPr>
@@ -16781,7 +16341,7 @@
       </p:sp>
       <p:sp>
         <p:nvSpPr>
-          <p:cNvPr id="20" name="Text 16"/>
+          <p:cNvPr id="18" name="Text 14"/>
           <p:cNvSpPr/>
           <p:nvPr/>
         </p:nvSpPr>
@@ -16823,7 +16383,7 @@
       </p:sp>
       <p:sp>
         <p:nvSpPr>
-          <p:cNvPr id="21" name="Shape 17"/>
+          <p:cNvPr id="19" name="Shape 15"/>
           <p:cNvSpPr/>
           <p:nvPr/>
         </p:nvSpPr>
@@ -16843,7 +16403,7 @@
       </p:sp>
       <p:sp>
         <p:nvSpPr>
-          <p:cNvPr id="22" name="Text 18"/>
+          <p:cNvPr id="20" name="Text 16"/>
           <p:cNvSpPr/>
           <p:nvPr/>
         </p:nvSpPr>
@@ -16882,7 +16442,7 @@
       </p:sp>
       <p:sp>
         <p:nvSpPr>
-          <p:cNvPr id="23" name="Text 19"/>
+          <p:cNvPr id="21" name="Text 17"/>
           <p:cNvSpPr/>
           <p:nvPr/>
         </p:nvSpPr>
@@ -16924,7 +16484,7 @@
       </p:sp>
       <p:sp>
         <p:nvSpPr>
-          <p:cNvPr id="24" name="Shape 20"/>
+          <p:cNvPr id="22" name="Shape 18"/>
           <p:cNvSpPr/>
           <p:nvPr/>
         </p:nvSpPr>
@@ -16939,16 +16499,14 @@
             </a:avLst>
           </a:prstGeom>
           <a:solidFill>
-            <a:srgbClr val="FFFFFF">
-              <a:alpha val="92000"/>
-            </a:srgbClr>
+            <a:srgbClr val="24685C"/>
           </a:solidFill>
           <a:ln/>
         </p:spPr>
       </p:sp>
       <p:sp>
         <p:nvSpPr>
-          <p:cNvPr id="25" name="Text 21"/>
+          <p:cNvPr id="23" name="Text 19"/>
           <p:cNvSpPr/>
           <p:nvPr/>
         </p:nvSpPr>
@@ -16987,7 +16545,7 @@
       </p:sp>
       <p:sp>
         <p:nvSpPr>
-          <p:cNvPr id="26" name="Text 22"/>
+          <p:cNvPr id="24" name="Text 20"/>
           <p:cNvSpPr/>
           <p:nvPr/>
         </p:nvSpPr>
@@ -17072,7 +16630,7 @@
       </p:sp>
       <p:sp>
         <p:nvSpPr>
-          <p:cNvPr id="28" name="Text 23"/>
+          <p:cNvPr id="26" name="Text 21"/>
           <p:cNvSpPr/>
           <p:nvPr/>
         </p:nvSpPr>
@@ -17111,7 +16669,7 @@
       </p:sp>
       <p:sp>
         <p:nvSpPr>
-          <p:cNvPr id="29" name="Text 24"/>
+          <p:cNvPr id="27" name="Text 22"/>
           <p:cNvSpPr/>
           <p:nvPr/>
         </p:nvSpPr>
@@ -17175,7 +16733,7 @@
       </p:grpSpPr>
       <p:pic>
         <p:nvPicPr>
-          <p:cNvPr id="2" name="Image 0" descr="/tmp/claude-0/-home-user-spanwerk-datenschutz/aecddc76-056b-54e2-a906-9229bc8dda84/scratchpad/final/bg_titel.jpg">    </p:cNvPr>
+          <p:cNvPr id="2" name="Image 0" descr="/tmp/claude-0/-home-user-spanwerk-datenschutz/aecddc76-056b-54e2-a906-9229bc8dda84/scratchpad/final/bg_titel_dark.jpg">    </p:cNvPr>
           <p:cNvPicPr>
             <a:picLocks noChangeAspect="1"/>
           </p:cNvPicPr>
@@ -17204,50 +16762,6 @@
         </p:nvSpPr>
         <p:spPr>
           <a:xfrm>
-            <a:off x="0" y="0"/>
-            <a:ext cx="12191695" cy="6858000"/>
-          </a:xfrm>
-          <a:prstGeom prst="rect">
-            <a:avLst/>
-          </a:prstGeom>
-          <a:solidFill>
-            <a:srgbClr val="24685C">
-              <a:alpha val="80000"/>
-            </a:srgbClr>
-          </a:solidFill>
-          <a:ln/>
-        </p:spPr>
-      </p:sp>
-      <p:sp>
-        <p:nvSpPr>
-          <p:cNvPr id="4" name="Shape 1"/>
-          <p:cNvSpPr/>
-          <p:nvPr/>
-        </p:nvSpPr>
-        <p:spPr>
-          <a:xfrm>
-            <a:off x="0" y="0"/>
-            <a:ext cx="12191695" cy="6858000"/>
-          </a:xfrm>
-          <a:prstGeom prst="rect">
-            <a:avLst/>
-          </a:prstGeom>
-          <a:solidFill>
-            <a:srgbClr val="24685C">
-              <a:alpha val="84000"/>
-            </a:srgbClr>
-          </a:solidFill>
-          <a:ln/>
-        </p:spPr>
-      </p:sp>
-      <p:sp>
-        <p:nvSpPr>
-          <p:cNvPr id="5" name="Shape 2"/>
-          <p:cNvSpPr/>
-          <p:nvPr/>
-        </p:nvSpPr>
-        <p:spPr>
-          <a:xfrm>
             <a:off x="5410048" y="1737360"/>
             <a:ext cx="1371600" cy="1371600"/>
           </a:xfrm>
@@ -17262,7 +16776,7 @@
       </p:sp>
       <p:pic>
         <p:nvPicPr>
-          <p:cNvPr id="6" name="Image 1" descr="preencoded.png">    </p:cNvPr>
+          <p:cNvPr id="4" name="Image 1" descr="preencoded.png">    </p:cNvPr>
           <p:cNvPicPr>
             <a:picLocks noChangeAspect="1"/>
           </p:cNvPicPr>
@@ -17286,7 +16800,7 @@
       </p:pic>
       <p:sp>
         <p:nvSpPr>
-          <p:cNvPr id="7" name="Text 3"/>
+          <p:cNvPr id="5" name="Text 1"/>
           <p:cNvSpPr/>
           <p:nvPr/>
         </p:nvSpPr>
@@ -17325,7 +16839,7 @@
       </p:sp>
       <p:sp>
         <p:nvSpPr>
-          <p:cNvPr id="8" name="Text 4"/>
+          <p:cNvPr id="6" name="Text 2"/>
           <p:cNvSpPr/>
           <p:nvPr/>
         </p:nvSpPr>
@@ -17364,7 +16878,7 @@
       </p:sp>
       <p:sp>
         <p:nvSpPr>
-          <p:cNvPr id="9" name="Text 5"/>
+          <p:cNvPr id="7" name="Text 3"/>
           <p:cNvSpPr/>
           <p:nvPr/>
         </p:nvSpPr>
@@ -17403,7 +16917,7 @@
       </p:sp>
       <p:sp>
         <p:nvSpPr>
-          <p:cNvPr id="11" name="Text 6"/>
+          <p:cNvPr id="9" name="Text 4"/>
           <p:cNvSpPr/>
           <p:nvPr/>
         </p:nvSpPr>
@@ -17442,7 +16956,7 @@
       </p:sp>
       <p:sp>
         <p:nvSpPr>
-          <p:cNvPr id="12" name="Text 7"/>
+          <p:cNvPr id="10" name="Text 5"/>
           <p:cNvSpPr/>
           <p:nvPr/>
         </p:nvSpPr>
@@ -17506,7 +17020,7 @@
       </p:grpSpPr>
       <p:pic>
         <p:nvPicPr>
-          <p:cNvPr id="2" name="Image 0" descr="/tmp/claude-0/-home-user-spanwerk-datenschutz/aecddc76-056b-54e2-a906-9229bc8dda84/scratchpad/final/bg_natur.jpg">    </p:cNvPr>
+          <p:cNvPr id="2" name="Image 0" descr="/tmp/claude-0/-home-user-spanwerk-datenschutz/aecddc76-056b-54e2-a906-9229bc8dda84/scratchpad/final/bg_natur_dark.jpg">    </p:cNvPr>
           <p:cNvPicPr>
             <a:picLocks noChangeAspect="1"/>
           </p:cNvPicPr>
@@ -17529,51 +17043,7 @@
       </p:pic>
       <p:sp>
         <p:nvSpPr>
-          <p:cNvPr id="3" name="Shape 0"/>
-          <p:cNvSpPr/>
-          <p:nvPr/>
-        </p:nvSpPr>
-        <p:spPr>
-          <a:xfrm>
-            <a:off x="0" y="0"/>
-            <a:ext cx="12191695" cy="6858000"/>
-          </a:xfrm>
-          <a:prstGeom prst="rect">
-            <a:avLst/>
-          </a:prstGeom>
-          <a:solidFill>
-            <a:srgbClr val="24685C">
-              <a:alpha val="80000"/>
-            </a:srgbClr>
-          </a:solidFill>
-          <a:ln/>
-        </p:spPr>
-      </p:sp>
-      <p:sp>
-        <p:nvSpPr>
-          <p:cNvPr id="4" name="Shape 1"/>
-          <p:cNvSpPr/>
-          <p:nvPr/>
-        </p:nvSpPr>
-        <p:spPr>
-          <a:xfrm>
-            <a:off x="0" y="0"/>
-            <a:ext cx="12191695" cy="6858000"/>
-          </a:xfrm>
-          <a:prstGeom prst="rect">
-            <a:avLst/>
-          </a:prstGeom>
-          <a:solidFill>
-            <a:srgbClr val="24685C">
-              <a:alpha val="86000"/>
-            </a:srgbClr>
-          </a:solidFill>
-          <a:ln/>
-        </p:spPr>
-      </p:sp>
-      <p:sp>
-        <p:nvSpPr>
-          <p:cNvPr id="5" name="Text 2"/>
+          <p:cNvPr id="3" name="Text 0"/>
           <p:cNvSpPr/>
           <p:nvPr/>
         </p:nvSpPr>
@@ -17612,7 +17082,7 @@
       </p:sp>
       <p:sp>
         <p:nvSpPr>
-          <p:cNvPr id="6" name="Text 3"/>
+          <p:cNvPr id="4" name="Text 1"/>
           <p:cNvSpPr/>
           <p:nvPr/>
         </p:nvSpPr>
@@ -17651,7 +17121,7 @@
       </p:sp>
       <p:sp>
         <p:nvSpPr>
-          <p:cNvPr id="7" name="Text 4"/>
+          <p:cNvPr id="5" name="Text 2"/>
           <p:cNvSpPr/>
           <p:nvPr/>
         </p:nvSpPr>
@@ -17693,7 +17163,7 @@
       </p:sp>
       <p:sp>
         <p:nvSpPr>
-          <p:cNvPr id="9" name="Text 5"/>
+          <p:cNvPr id="7" name="Text 3"/>
           <p:cNvSpPr/>
           <p:nvPr/>
         </p:nvSpPr>
@@ -17732,7 +17202,7 @@
       </p:sp>
       <p:sp>
         <p:nvSpPr>
-          <p:cNvPr id="10" name="Text 6"/>
+          <p:cNvPr id="8" name="Text 4"/>
           <p:cNvSpPr/>
           <p:nvPr/>
         </p:nvSpPr>
@@ -21966,7 +21436,7 @@
       </p:grpSpPr>
       <p:pic>
         <p:nvPicPr>
-          <p:cNvPr id="2" name="Image 0" descr="/tmp/claude-0/-home-user-spanwerk-datenschutz/aecddc76-056b-54e2-a906-9229bc8dda84/scratchpad/final/bg_natur.jpg">    </p:cNvPr>
+          <p:cNvPr id="2" name="Image 0" descr="/tmp/claude-0/-home-user-spanwerk-datenschutz/aecddc76-056b-54e2-a906-9229bc8dda84/scratchpad/final/bg_natur_dark.jpg">    </p:cNvPr>
           <p:cNvPicPr>
             <a:picLocks noChangeAspect="1"/>
           </p:cNvPicPr>
@@ -21989,51 +21459,7 @@
       </p:pic>
       <p:sp>
         <p:nvSpPr>
-          <p:cNvPr id="3" name="Shape 0"/>
-          <p:cNvSpPr/>
-          <p:nvPr/>
-        </p:nvSpPr>
-        <p:spPr>
-          <a:xfrm>
-            <a:off x="0" y="0"/>
-            <a:ext cx="12191695" cy="6858000"/>
-          </a:xfrm>
-          <a:prstGeom prst="rect">
-            <a:avLst/>
-          </a:prstGeom>
-          <a:solidFill>
-            <a:srgbClr val="24685C">
-              <a:alpha val="84000"/>
-            </a:srgbClr>
-          </a:solidFill>
-          <a:ln/>
-        </p:spPr>
-      </p:sp>
-      <p:sp>
-        <p:nvSpPr>
-          <p:cNvPr id="4" name="Shape 1"/>
-          <p:cNvSpPr/>
-          <p:nvPr/>
-        </p:nvSpPr>
-        <p:spPr>
-          <a:xfrm>
-            <a:off x="0" y="0"/>
-            <a:ext cx="12191695" cy="6858000"/>
-          </a:xfrm>
-          <a:prstGeom prst="rect">
-            <a:avLst/>
-          </a:prstGeom>
-          <a:solidFill>
-            <a:srgbClr val="24685C">
-              <a:alpha val="88000"/>
-            </a:srgbClr>
-          </a:solidFill>
-          <a:ln/>
-        </p:spPr>
-      </p:sp>
-      <p:sp>
-        <p:nvSpPr>
-          <p:cNvPr id="5" name="Text 2"/>
+          <p:cNvPr id="3" name="Text 0"/>
           <p:cNvSpPr/>
           <p:nvPr/>
         </p:nvSpPr>
@@ -22072,7 +21498,7 @@
       </p:sp>
       <p:sp>
         <p:nvSpPr>
-          <p:cNvPr id="6" name="Text 3"/>
+          <p:cNvPr id="4" name="Text 1"/>
           <p:cNvSpPr/>
           <p:nvPr/>
         </p:nvSpPr>
@@ -22111,7 +21537,7 @@
       </p:sp>
       <p:sp>
         <p:nvSpPr>
-          <p:cNvPr id="7" name="Shape 4"/>
+          <p:cNvPr id="5" name="Shape 2"/>
           <p:cNvSpPr/>
           <p:nvPr/>
         </p:nvSpPr>
@@ -22126,16 +21552,14 @@
             </a:avLst>
           </a:prstGeom>
           <a:solidFill>
-            <a:srgbClr val="FFFFFF">
-              <a:alpha val="92000"/>
-            </a:srgbClr>
+            <a:srgbClr val="FFFFFF"/>
           </a:solidFill>
           <a:ln/>
         </p:spPr>
       </p:sp>
       <p:sp>
         <p:nvSpPr>
-          <p:cNvPr id="8" name="Shape 5"/>
+          <p:cNvPr id="6" name="Shape 3"/>
           <p:cNvSpPr/>
           <p:nvPr/>
         </p:nvSpPr>
@@ -22155,7 +21579,7 @@
       </p:sp>
       <p:pic>
         <p:nvPicPr>
-          <p:cNvPr id="9" name="Image 1" descr="preencoded.png">    </p:cNvPr>
+          <p:cNvPr id="7" name="Image 1" descr="preencoded.png">    </p:cNvPr>
           <p:cNvPicPr>
             <a:picLocks noChangeAspect="1"/>
           </p:cNvPicPr>
@@ -22179,7 +21603,7 @@
       </p:pic>
       <p:sp>
         <p:nvSpPr>
-          <p:cNvPr id="10" name="Text 6"/>
+          <p:cNvPr id="8" name="Text 4"/>
           <p:cNvSpPr/>
           <p:nvPr/>
         </p:nvSpPr>
@@ -22218,7 +21642,7 @@
       </p:sp>
       <p:sp>
         <p:nvSpPr>
-          <p:cNvPr id="11" name="Text 7"/>
+          <p:cNvPr id="9" name="Text 5"/>
           <p:cNvSpPr/>
           <p:nvPr/>
         </p:nvSpPr>
@@ -22257,7 +21681,7 @@
       </p:sp>
       <p:sp>
         <p:nvSpPr>
-          <p:cNvPr id="12" name="Shape 8"/>
+          <p:cNvPr id="10" name="Shape 6"/>
           <p:cNvSpPr/>
           <p:nvPr/>
         </p:nvSpPr>
@@ -22272,16 +21696,14 @@
             </a:avLst>
           </a:prstGeom>
           <a:solidFill>
-            <a:srgbClr val="FFFFFF">
-              <a:alpha val="92000"/>
-            </a:srgbClr>
+            <a:srgbClr val="FFFFFF"/>
           </a:solidFill>
           <a:ln/>
         </p:spPr>
       </p:sp>
       <p:sp>
         <p:nvSpPr>
-          <p:cNvPr id="13" name="Shape 9"/>
+          <p:cNvPr id="11" name="Shape 7"/>
           <p:cNvSpPr/>
           <p:nvPr/>
         </p:nvSpPr>
@@ -22301,7 +21723,7 @@
       </p:sp>
       <p:pic>
         <p:nvPicPr>
-          <p:cNvPr id="14" name="Image 2" descr="preencoded.png">    </p:cNvPr>
+          <p:cNvPr id="12" name="Image 2" descr="preencoded.png">    </p:cNvPr>
           <p:cNvPicPr>
             <a:picLocks noChangeAspect="1"/>
           </p:cNvPicPr>
@@ -22325,7 +21747,7 @@
       </p:pic>
       <p:sp>
         <p:nvSpPr>
-          <p:cNvPr id="15" name="Text 10"/>
+          <p:cNvPr id="13" name="Text 8"/>
           <p:cNvSpPr/>
           <p:nvPr/>
         </p:nvSpPr>
@@ -22364,7 +21786,7 @@
       </p:sp>
       <p:sp>
         <p:nvSpPr>
-          <p:cNvPr id="16" name="Text 11"/>
+          <p:cNvPr id="14" name="Text 9"/>
           <p:cNvSpPr/>
           <p:nvPr/>
         </p:nvSpPr>
@@ -22403,7 +21825,7 @@
       </p:sp>
       <p:sp>
         <p:nvSpPr>
-          <p:cNvPr id="17" name="Shape 12"/>
+          <p:cNvPr id="15" name="Shape 10"/>
           <p:cNvSpPr/>
           <p:nvPr/>
         </p:nvSpPr>
@@ -22418,16 +21840,14 @@
             </a:avLst>
           </a:prstGeom>
           <a:solidFill>
-            <a:srgbClr val="FFFFFF">
-              <a:alpha val="92000"/>
-            </a:srgbClr>
+            <a:srgbClr val="FFFFFF"/>
           </a:solidFill>
           <a:ln/>
         </p:spPr>
       </p:sp>
       <p:sp>
         <p:nvSpPr>
-          <p:cNvPr id="18" name="Shape 13"/>
+          <p:cNvPr id="16" name="Shape 11"/>
           <p:cNvSpPr/>
           <p:nvPr/>
         </p:nvSpPr>
@@ -22447,7 +21867,7 @@
       </p:sp>
       <p:pic>
         <p:nvPicPr>
-          <p:cNvPr id="19" name="Image 3" descr="preencoded.png">    </p:cNvPr>
+          <p:cNvPr id="17" name="Image 3" descr="preencoded.png">    </p:cNvPr>
           <p:cNvPicPr>
             <a:picLocks noChangeAspect="1"/>
           </p:cNvPicPr>
@@ -22471,7 +21891,7 @@
       </p:pic>
       <p:sp>
         <p:nvSpPr>
-          <p:cNvPr id="20" name="Text 14"/>
+          <p:cNvPr id="18" name="Text 12"/>
           <p:cNvSpPr/>
           <p:nvPr/>
         </p:nvSpPr>
@@ -22510,7 +21930,7 @@
       </p:sp>
       <p:sp>
         <p:nvSpPr>
-          <p:cNvPr id="21" name="Text 15"/>
+          <p:cNvPr id="19" name="Text 13"/>
           <p:cNvSpPr/>
           <p:nvPr/>
         </p:nvSpPr>
@@ -22549,7 +21969,7 @@
       </p:sp>
       <p:sp>
         <p:nvSpPr>
-          <p:cNvPr id="22" name="Shape 16"/>
+          <p:cNvPr id="20" name="Shape 14"/>
           <p:cNvSpPr/>
           <p:nvPr/>
         </p:nvSpPr>
@@ -22564,16 +21984,14 @@
             </a:avLst>
           </a:prstGeom>
           <a:solidFill>
-            <a:srgbClr val="FFFFFF">
-              <a:alpha val="92000"/>
-            </a:srgbClr>
+            <a:srgbClr val="FFFFFF"/>
           </a:solidFill>
           <a:ln/>
         </p:spPr>
       </p:sp>
       <p:sp>
         <p:nvSpPr>
-          <p:cNvPr id="23" name="Shape 17"/>
+          <p:cNvPr id="21" name="Shape 15"/>
           <p:cNvSpPr/>
           <p:nvPr/>
         </p:nvSpPr>
@@ -22593,7 +22011,7 @@
       </p:sp>
       <p:pic>
         <p:nvPicPr>
-          <p:cNvPr id="24" name="Image 4" descr="preencoded.png">    </p:cNvPr>
+          <p:cNvPr id="22" name="Image 4" descr="preencoded.png">    </p:cNvPr>
           <p:cNvPicPr>
             <a:picLocks noChangeAspect="1"/>
           </p:cNvPicPr>
@@ -22617,7 +22035,7 @@
       </p:pic>
       <p:sp>
         <p:nvSpPr>
-          <p:cNvPr id="25" name="Text 18"/>
+          <p:cNvPr id="23" name="Text 16"/>
           <p:cNvSpPr/>
           <p:nvPr/>
         </p:nvSpPr>
@@ -22656,7 +22074,7 @@
       </p:sp>
       <p:sp>
         <p:nvSpPr>
-          <p:cNvPr id="26" name="Text 19"/>
+          <p:cNvPr id="24" name="Text 17"/>
           <p:cNvSpPr/>
           <p:nvPr/>
         </p:nvSpPr>
@@ -22695,7 +22113,7 @@
       </p:sp>
       <p:sp>
         <p:nvSpPr>
-          <p:cNvPr id="27" name="Text 20"/>
+          <p:cNvPr id="25" name="Text 18"/>
           <p:cNvSpPr/>
           <p:nvPr/>
         </p:nvSpPr>
@@ -22734,7 +22152,7 @@
       </p:sp>
       <p:sp>
         <p:nvSpPr>
-          <p:cNvPr id="29" name="Text 21"/>
+          <p:cNvPr id="27" name="Text 19"/>
           <p:cNvSpPr/>
           <p:nvPr/>
         </p:nvSpPr>
@@ -22773,7 +22191,7 @@
       </p:sp>
       <p:sp>
         <p:nvSpPr>
-          <p:cNvPr id="30" name="Text 22"/>
+          <p:cNvPr id="28" name="Text 20"/>
           <p:cNvSpPr/>
           <p:nvPr/>
         </p:nvSpPr>
@@ -22837,7 +22255,7 @@
       </p:grpSpPr>
       <p:pic>
         <p:nvPicPr>
-          <p:cNvPr id="2" name="Image 0" descr="/tmp/claude-0/-home-user-spanwerk-datenschutz/aecddc76-056b-54e2-a906-9229bc8dda84/scratchpad/final/bg_natur.jpg">    </p:cNvPr>
+          <p:cNvPr id="2" name="Image 0" descr="/tmp/claude-0/-home-user-spanwerk-datenschutz/aecddc76-056b-54e2-a906-9229bc8dda84/scratchpad/final/bg_natur_dark.jpg">    </p:cNvPr>
           <p:cNvPicPr>
             <a:picLocks noChangeAspect="1"/>
           </p:cNvPicPr>
@@ -22866,50 +22284,6 @@
         </p:nvSpPr>
         <p:spPr>
           <a:xfrm>
-            <a:off x="0" y="0"/>
-            <a:ext cx="12191695" cy="6858000"/>
-          </a:xfrm>
-          <a:prstGeom prst="rect">
-            <a:avLst/>
-          </a:prstGeom>
-          <a:solidFill>
-            <a:srgbClr val="24685C">
-              <a:alpha val="88000"/>
-            </a:srgbClr>
-          </a:solidFill>
-          <a:ln/>
-        </p:spPr>
-      </p:sp>
-      <p:sp>
-        <p:nvSpPr>
-          <p:cNvPr id="4" name="Shape 1"/>
-          <p:cNvSpPr/>
-          <p:nvPr/>
-        </p:nvSpPr>
-        <p:spPr>
-          <a:xfrm>
-            <a:off x="0" y="0"/>
-            <a:ext cx="4114800" cy="6858000"/>
-          </a:xfrm>
-          <a:prstGeom prst="rect">
-            <a:avLst/>
-          </a:prstGeom>
-          <a:solidFill>
-            <a:srgbClr val="24685C">
-              <a:alpha val="92000"/>
-            </a:srgbClr>
-          </a:solidFill>
-          <a:ln/>
-        </p:spPr>
-      </p:sp>
-      <p:sp>
-        <p:nvSpPr>
-          <p:cNvPr id="5" name="Shape 2"/>
-          <p:cNvSpPr/>
-          <p:nvPr/>
-        </p:nvSpPr>
-        <p:spPr>
-          <a:xfrm>
             <a:off x="1371600" y="1097280"/>
             <a:ext cx="1371600" cy="1371600"/>
           </a:xfrm>
@@ -22924,7 +22298,7 @@
       </p:sp>
       <p:pic>
         <p:nvPicPr>
-          <p:cNvPr id="6" name="Image 1" descr="preencoded.png">    </p:cNvPr>
+          <p:cNvPr id="4" name="Image 1" descr="preencoded.png">    </p:cNvPr>
           <p:cNvPicPr>
             <a:picLocks noChangeAspect="1"/>
           </p:cNvPicPr>
@@ -22948,7 +22322,7 @@
       </p:pic>
       <p:sp>
         <p:nvSpPr>
-          <p:cNvPr id="7" name="Text 3"/>
+          <p:cNvPr id="5" name="Text 1"/>
           <p:cNvSpPr/>
           <p:nvPr/>
         </p:nvSpPr>
@@ -22987,7 +22361,7 @@
       </p:sp>
       <p:sp>
         <p:nvSpPr>
-          <p:cNvPr id="8" name="Text 4"/>
+          <p:cNvPr id="6" name="Text 2"/>
           <p:cNvSpPr/>
           <p:nvPr/>
         </p:nvSpPr>
@@ -23026,7 +22400,7 @@
       </p:sp>
       <p:sp>
         <p:nvSpPr>
-          <p:cNvPr id="9" name="Shape 5"/>
+          <p:cNvPr id="7" name="Shape 3"/>
           <p:cNvSpPr/>
           <p:nvPr/>
         </p:nvSpPr>
@@ -23048,7 +22422,7 @@
       </p:sp>
       <p:sp>
         <p:nvSpPr>
-          <p:cNvPr id="10" name="Text 6"/>
+          <p:cNvPr id="8" name="Text 4"/>
           <p:cNvSpPr/>
           <p:nvPr/>
         </p:nvSpPr>
@@ -23087,7 +22461,7 @@
       </p:sp>
       <p:sp>
         <p:nvSpPr>
-          <p:cNvPr id="11" name="Text 7"/>
+          <p:cNvPr id="9" name="Text 5"/>
           <p:cNvSpPr/>
           <p:nvPr/>
         </p:nvSpPr>
@@ -23126,7 +22500,7 @@
       </p:sp>
       <p:sp>
         <p:nvSpPr>
-          <p:cNvPr id="12" name="Shape 8"/>
+          <p:cNvPr id="10" name="Shape 6"/>
           <p:cNvSpPr/>
           <p:nvPr/>
         </p:nvSpPr>
@@ -23146,7 +22520,7 @@
       </p:sp>
       <p:sp>
         <p:nvSpPr>
-          <p:cNvPr id="13" name="Text 9"/>
+          <p:cNvPr id="11" name="Text 7"/>
           <p:cNvSpPr/>
           <p:nvPr/>
         </p:nvSpPr>
@@ -23185,7 +22559,7 @@
       </p:sp>
       <p:sp>
         <p:nvSpPr>
-          <p:cNvPr id="14" name="Text 10"/>
+          <p:cNvPr id="12" name="Text 8"/>
           <p:cNvSpPr/>
           <p:nvPr/>
         </p:nvSpPr>
@@ -23227,7 +22601,7 @@
       </p:sp>
       <p:sp>
         <p:nvSpPr>
-          <p:cNvPr id="15" name="Shape 11"/>
+          <p:cNvPr id="13" name="Shape 9"/>
           <p:cNvSpPr/>
           <p:nvPr/>
         </p:nvSpPr>
@@ -23247,7 +22621,7 @@
       </p:sp>
       <p:sp>
         <p:nvSpPr>
-          <p:cNvPr id="16" name="Text 12"/>
+          <p:cNvPr id="14" name="Text 10"/>
           <p:cNvSpPr/>
           <p:nvPr/>
         </p:nvSpPr>
@@ -23286,7 +22660,7 @@
       </p:sp>
       <p:sp>
         <p:nvSpPr>
-          <p:cNvPr id="17" name="Text 13"/>
+          <p:cNvPr id="15" name="Text 11"/>
           <p:cNvSpPr/>
           <p:nvPr/>
         </p:nvSpPr>
@@ -23328,7 +22702,7 @@
       </p:sp>
       <p:sp>
         <p:nvSpPr>
-          <p:cNvPr id="18" name="Shape 14"/>
+          <p:cNvPr id="16" name="Shape 12"/>
           <p:cNvSpPr/>
           <p:nvPr/>
         </p:nvSpPr>
@@ -23348,7 +22722,7 @@
       </p:sp>
       <p:sp>
         <p:nvSpPr>
-          <p:cNvPr id="19" name="Text 15"/>
+          <p:cNvPr id="17" name="Text 13"/>
           <p:cNvSpPr/>
           <p:nvPr/>
         </p:nvSpPr>
@@ -23387,7 +22761,7 @@
       </p:sp>
       <p:sp>
         <p:nvSpPr>
-          <p:cNvPr id="20" name="Text 16"/>
+          <p:cNvPr id="18" name="Text 14"/>
           <p:cNvSpPr/>
           <p:nvPr/>
         </p:nvSpPr>
@@ -23429,7 +22803,7 @@
       </p:sp>
       <p:sp>
         <p:nvSpPr>
-          <p:cNvPr id="21" name="Shape 17"/>
+          <p:cNvPr id="19" name="Shape 15"/>
           <p:cNvSpPr/>
           <p:nvPr/>
         </p:nvSpPr>
@@ -23449,7 +22823,7 @@
       </p:sp>
       <p:sp>
         <p:nvSpPr>
-          <p:cNvPr id="22" name="Text 18"/>
+          <p:cNvPr id="20" name="Text 16"/>
           <p:cNvSpPr/>
           <p:nvPr/>
         </p:nvSpPr>
@@ -23488,7 +22862,7 @@
       </p:sp>
       <p:sp>
         <p:nvSpPr>
-          <p:cNvPr id="23" name="Text 19"/>
+          <p:cNvPr id="21" name="Text 17"/>
           <p:cNvSpPr/>
           <p:nvPr/>
         </p:nvSpPr>
@@ -23530,7 +22904,7 @@
       </p:sp>
       <p:sp>
         <p:nvSpPr>
-          <p:cNvPr id="24" name="Shape 20"/>
+          <p:cNvPr id="22" name="Shape 18"/>
           <p:cNvSpPr/>
           <p:nvPr/>
         </p:nvSpPr>
@@ -23545,16 +22919,14 @@
             </a:avLst>
           </a:prstGeom>
           <a:solidFill>
-            <a:srgbClr val="FFFFFF">
-              <a:alpha val="92000"/>
-            </a:srgbClr>
+            <a:srgbClr val="24685C"/>
           </a:solidFill>
           <a:ln/>
         </p:spPr>
       </p:sp>
       <p:sp>
         <p:nvSpPr>
-          <p:cNvPr id="25" name="Text 21"/>
+          <p:cNvPr id="23" name="Text 19"/>
           <p:cNvSpPr/>
           <p:nvPr/>
         </p:nvSpPr>
@@ -23593,7 +22965,7 @@
       </p:sp>
       <p:sp>
         <p:nvSpPr>
-          <p:cNvPr id="26" name="Text 22"/>
+          <p:cNvPr id="24" name="Text 20"/>
           <p:cNvSpPr/>
           <p:nvPr/>
         </p:nvSpPr>
@@ -23678,7 +23050,7 @@
       </p:sp>
       <p:sp>
         <p:nvSpPr>
-          <p:cNvPr id="28" name="Text 23"/>
+          <p:cNvPr id="26" name="Text 21"/>
           <p:cNvSpPr/>
           <p:nvPr/>
         </p:nvSpPr>
@@ -23717,7 +23089,7 @@
       </p:sp>
       <p:sp>
         <p:nvSpPr>
-          <p:cNvPr id="29" name="Text 24"/>
+          <p:cNvPr id="27" name="Text 22"/>
           <p:cNvSpPr/>
           <p:nvPr/>
         </p:nvSpPr>
@@ -23781,7 +23153,7 @@
       </p:grpSpPr>
       <p:pic>
         <p:nvPicPr>
-          <p:cNvPr id="2" name="Image 0" descr="/tmp/claude-0/-home-user-spanwerk-datenschutz/aecddc76-056b-54e2-a906-9229bc8dda84/scratchpad/final/bg_natur.jpg">    </p:cNvPr>
+          <p:cNvPr id="2" name="Image 0" descr="/tmp/claude-0/-home-user-spanwerk-datenschutz/aecddc76-056b-54e2-a906-9229bc8dda84/scratchpad/final/bg_natur_dark.jpg">    </p:cNvPr>
           <p:cNvPicPr>
             <a:picLocks noChangeAspect="1"/>
           </p:cNvPicPr>
@@ -23804,51 +23176,7 @@
       </p:pic>
       <p:sp>
         <p:nvSpPr>
-          <p:cNvPr id="3" name="Shape 0"/>
-          <p:cNvSpPr/>
-          <p:nvPr/>
-        </p:nvSpPr>
-        <p:spPr>
-          <a:xfrm>
-            <a:off x="0" y="0"/>
-            <a:ext cx="12191695" cy="6858000"/>
-          </a:xfrm>
-          <a:prstGeom prst="rect">
-            <a:avLst/>
-          </a:prstGeom>
-          <a:solidFill>
-            <a:srgbClr val="24685C">
-              <a:alpha val="80000"/>
-            </a:srgbClr>
-          </a:solidFill>
-          <a:ln/>
-        </p:spPr>
-      </p:sp>
-      <p:sp>
-        <p:nvSpPr>
-          <p:cNvPr id="4" name="Shape 1"/>
-          <p:cNvSpPr/>
-          <p:nvPr/>
-        </p:nvSpPr>
-        <p:spPr>
-          <a:xfrm>
-            <a:off x="0" y="0"/>
-            <a:ext cx="12191695" cy="6858000"/>
-          </a:xfrm>
-          <a:prstGeom prst="rect">
-            <a:avLst/>
-          </a:prstGeom>
-          <a:solidFill>
-            <a:srgbClr val="24685C">
-              <a:alpha val="86000"/>
-            </a:srgbClr>
-          </a:solidFill>
-          <a:ln/>
-        </p:spPr>
-      </p:sp>
-      <p:sp>
-        <p:nvSpPr>
-          <p:cNvPr id="5" name="Text 2"/>
+          <p:cNvPr id="3" name="Text 0"/>
           <p:cNvSpPr/>
           <p:nvPr/>
         </p:nvSpPr>
@@ -23887,7 +23215,7 @@
       </p:sp>
       <p:sp>
         <p:nvSpPr>
-          <p:cNvPr id="6" name="Text 3"/>
+          <p:cNvPr id="4" name="Text 1"/>
           <p:cNvSpPr/>
           <p:nvPr/>
         </p:nvSpPr>
@@ -23926,7 +23254,7 @@
       </p:sp>
       <p:sp>
         <p:nvSpPr>
-          <p:cNvPr id="7" name="Text 4"/>
+          <p:cNvPr id="5" name="Text 2"/>
           <p:cNvSpPr/>
           <p:nvPr/>
         </p:nvSpPr>
@@ -23968,7 +23296,7 @@
       </p:sp>
       <p:sp>
         <p:nvSpPr>
-          <p:cNvPr id="9" name="Text 5"/>
+          <p:cNvPr id="7" name="Text 3"/>
           <p:cNvSpPr/>
           <p:nvPr/>
         </p:nvSpPr>
@@ -24007,7 +23335,7 @@
       </p:sp>
       <p:sp>
         <p:nvSpPr>
-          <p:cNvPr id="10" name="Text 6"/>
+          <p:cNvPr id="8" name="Text 4"/>
           <p:cNvSpPr/>
           <p:nvPr/>
         </p:nvSpPr>
@@ -26753,7 +26081,7 @@
       </p:grpSpPr>
       <p:pic>
         <p:nvPicPr>
-          <p:cNvPr id="2" name="Image 0" descr="/tmp/claude-0/-home-user-spanwerk-datenschutz/aecddc76-056b-54e2-a906-9229bc8dda84/scratchpad/final/bg_titel.jpg">    </p:cNvPr>
+          <p:cNvPr id="2" name="Image 0" descr="/tmp/claude-0/-home-user-spanwerk-datenschutz/aecddc76-056b-54e2-a906-9229bc8dda84/scratchpad/final/bg_titel_dark.jpg">    </p:cNvPr>
           <p:cNvPicPr>
             <a:picLocks noChangeAspect="1"/>
           </p:cNvPicPr>
@@ -26782,50 +26110,6 @@
         </p:nvSpPr>
         <p:spPr>
           <a:xfrm>
-            <a:off x="0" y="0"/>
-            <a:ext cx="12191695" cy="6858000"/>
-          </a:xfrm>
-          <a:prstGeom prst="rect">
-            <a:avLst/>
-          </a:prstGeom>
-          <a:solidFill>
-            <a:srgbClr val="24685C">
-              <a:alpha val="82000"/>
-            </a:srgbClr>
-          </a:solidFill>
-          <a:ln/>
-        </p:spPr>
-      </p:sp>
-      <p:sp>
-        <p:nvSpPr>
-          <p:cNvPr id="4" name="Shape 1"/>
-          <p:cNvSpPr/>
-          <p:nvPr/>
-        </p:nvSpPr>
-        <p:spPr>
-          <a:xfrm>
-            <a:off x="0" y="0"/>
-            <a:ext cx="7680960" cy="6858000"/>
-          </a:xfrm>
-          <a:prstGeom prst="rect">
-            <a:avLst/>
-          </a:prstGeom>
-          <a:solidFill>
-            <a:srgbClr val="24685C">
-              <a:alpha val="82000"/>
-            </a:srgbClr>
-          </a:solidFill>
-          <a:ln/>
-        </p:spPr>
-      </p:sp>
-      <p:sp>
-        <p:nvSpPr>
-          <p:cNvPr id="5" name="Shape 2"/>
-          <p:cNvSpPr/>
-          <p:nvPr/>
-        </p:nvSpPr>
-        <p:spPr>
-          <a:xfrm>
             <a:off x="566928" y="777240"/>
             <a:ext cx="914400" cy="914400"/>
           </a:xfrm>
@@ -26840,7 +26124,7 @@
       </p:sp>
       <p:pic>
         <p:nvPicPr>
-          <p:cNvPr id="6" name="Image 1" descr="preencoded.png">    </p:cNvPr>
+          <p:cNvPr id="4" name="Image 1" descr="preencoded.png">    </p:cNvPr>
           <p:cNvPicPr>
             <a:picLocks noChangeAspect="1"/>
           </p:cNvPicPr>
@@ -26864,7 +26148,7 @@
       </p:pic>
       <p:sp>
         <p:nvSpPr>
-          <p:cNvPr id="7" name="Text 3"/>
+          <p:cNvPr id="5" name="Text 1"/>
           <p:cNvSpPr/>
           <p:nvPr/>
         </p:nvSpPr>
@@ -26903,7 +26187,7 @@
       </p:sp>
       <p:sp>
         <p:nvSpPr>
-          <p:cNvPr id="8" name="Text 4"/>
+          <p:cNvPr id="6" name="Text 2"/>
           <p:cNvSpPr/>
           <p:nvPr/>
         </p:nvSpPr>
@@ -26942,7 +26226,7 @@
       </p:sp>
       <p:sp>
         <p:nvSpPr>
-          <p:cNvPr id="9" name="Text 5"/>
+          <p:cNvPr id="7" name="Text 3"/>
           <p:cNvSpPr/>
           <p:nvPr/>
         </p:nvSpPr>
@@ -26999,7 +26283,7 @@
       </p:sp>
       <p:sp>
         <p:nvSpPr>
-          <p:cNvPr id="11" name="Text 6"/>
+          <p:cNvPr id="9" name="Text 4"/>
           <p:cNvSpPr/>
           <p:nvPr/>
         </p:nvSpPr>
@@ -27038,7 +26322,7 @@
       </p:sp>
       <p:sp>
         <p:nvSpPr>
-          <p:cNvPr id="12" name="Text 7"/>
+          <p:cNvPr id="10" name="Text 5"/>
           <p:cNvSpPr/>
           <p:nvPr/>
         </p:nvSpPr>
@@ -28178,9 +27462,7 @@
             </a:avLst>
           </a:prstGeom>
           <a:solidFill>
-            <a:srgbClr val="FFFFFF">
-              <a:alpha val="92000"/>
-            </a:srgbClr>
+            <a:srgbClr val="FFFFFF"/>
           </a:solidFill>
           <a:ln/>
         </p:spPr>
@@ -28200,7 +27482,7 @@
             <a:avLst/>
           </a:prstGeom>
           <a:solidFill>
-            <a:srgbClr val="6FBE9C"/>
+            <a:srgbClr val="2E9284"/>
           </a:solidFill>
           <a:ln/>
         </p:spPr>
@@ -28256,7 +27538,7 @@
             <a:r>
               <a:rPr lang="en-US" sz="1500" b="1" dirty="0">
                 <a:solidFill>
-                  <a:srgbClr val="FFFFFF"/>
+                  <a:srgbClr val="2C7A6B"/>
                 </a:solidFill>
                 <a:latin typeface="Cambria" pitchFamily="34" charset="0"/>
                 <a:ea typeface="Cambria" pitchFamily="34" charset="-122"/>
@@ -28295,7 +27577,7 @@
             <a:r>
               <a:rPr lang="en-US" sz="1250" dirty="0">
                 <a:solidFill>
-                  <a:srgbClr val="EAF6EF"/>
+                  <a:srgbClr val="23423C"/>
                 </a:solidFill>
                 <a:latin typeface="Calibri" pitchFamily="34" charset="0"/>
                 <a:ea typeface="Calibri" pitchFamily="34" charset="-122"/>
@@ -28324,9 +27606,7 @@
             </a:avLst>
           </a:prstGeom>
           <a:solidFill>
-            <a:srgbClr val="FFFFFF">
-              <a:alpha val="92000"/>
-            </a:srgbClr>
+            <a:srgbClr val="FFFFFF"/>
           </a:solidFill>
           <a:ln/>
         </p:spPr>
@@ -28346,7 +27626,7 @@
             <a:avLst/>
           </a:prstGeom>
           <a:solidFill>
-            <a:srgbClr val="6FBE9C"/>
+            <a:srgbClr val="2E9284"/>
           </a:solidFill>
           <a:ln/>
         </p:spPr>
@@ -28402,7 +27682,7 @@
             <a:r>
               <a:rPr lang="en-US" sz="1500" b="1" dirty="0">
                 <a:solidFill>
-                  <a:srgbClr val="FFFFFF"/>
+                  <a:srgbClr val="2C7A6B"/>
                 </a:solidFill>
                 <a:latin typeface="Cambria" pitchFamily="34" charset="0"/>
                 <a:ea typeface="Cambria" pitchFamily="34" charset="-122"/>
@@ -28441,7 +27721,7 @@
             <a:r>
               <a:rPr lang="en-US" sz="1250" dirty="0">
                 <a:solidFill>
-                  <a:srgbClr val="EAF6EF"/>
+                  <a:srgbClr val="23423C"/>
                 </a:solidFill>
                 <a:latin typeface="Calibri" pitchFamily="34" charset="0"/>
                 <a:ea typeface="Calibri" pitchFamily="34" charset="-122"/>
@@ -28470,9 +27750,7 @@
             </a:avLst>
           </a:prstGeom>
           <a:solidFill>
-            <a:srgbClr val="FFFFFF">
-              <a:alpha val="92000"/>
-            </a:srgbClr>
+            <a:srgbClr val="FFFFFF"/>
           </a:solidFill>
           <a:ln/>
         </p:spPr>
@@ -28492,7 +27770,7 @@
             <a:avLst/>
           </a:prstGeom>
           <a:solidFill>
-            <a:srgbClr val="6FBE9C"/>
+            <a:srgbClr val="2E9284"/>
           </a:solidFill>
           <a:ln/>
         </p:spPr>
@@ -28548,7 +27826,7 @@
             <a:r>
               <a:rPr lang="en-US" sz="1500" b="1" dirty="0">
                 <a:solidFill>
-                  <a:srgbClr val="FFFFFF"/>
+                  <a:srgbClr val="2C7A6B"/>
                 </a:solidFill>
                 <a:latin typeface="Cambria" pitchFamily="34" charset="0"/>
                 <a:ea typeface="Cambria" pitchFamily="34" charset="-122"/>
@@ -28587,7 +27865,7 @@
             <a:r>
               <a:rPr lang="en-US" sz="1250" dirty="0">
                 <a:solidFill>
-                  <a:srgbClr val="EAF6EF"/>
+                  <a:srgbClr val="23423C"/>
                 </a:solidFill>
                 <a:latin typeface="Calibri" pitchFamily="34" charset="0"/>
                 <a:ea typeface="Calibri" pitchFamily="34" charset="-122"/>
@@ -28616,9 +27894,7 @@
             </a:avLst>
           </a:prstGeom>
           <a:solidFill>
-            <a:srgbClr val="FFFFFF">
-              <a:alpha val="92000"/>
-            </a:srgbClr>
+            <a:srgbClr val="FFFFFF"/>
           </a:solidFill>
           <a:ln/>
         </p:spPr>
@@ -28638,7 +27914,7 @@
             <a:avLst/>
           </a:prstGeom>
           <a:solidFill>
-            <a:srgbClr val="6FBE9C"/>
+            <a:srgbClr val="2E9284"/>
           </a:solidFill>
           <a:ln/>
         </p:spPr>
@@ -28694,7 +27970,7 @@
             <a:r>
               <a:rPr lang="en-US" sz="1500" b="1" dirty="0">
                 <a:solidFill>
-                  <a:srgbClr val="FFFFFF"/>
+                  <a:srgbClr val="2C7A6B"/>
                 </a:solidFill>
                 <a:latin typeface="Cambria" pitchFamily="34" charset="0"/>
                 <a:ea typeface="Cambria" pitchFamily="34" charset="-122"/>
@@ -28733,7 +28009,7 @@
             <a:r>
               <a:rPr lang="en-US" sz="1250" dirty="0">
                 <a:solidFill>
-                  <a:srgbClr val="EAF6EF"/>
+                  <a:srgbClr val="23423C"/>
                 </a:solidFill>
                 <a:latin typeface="Calibri" pitchFamily="34" charset="0"/>
                 <a:ea typeface="Calibri" pitchFamily="34" charset="-122"/>
@@ -28762,9 +28038,7 @@
             </a:avLst>
           </a:prstGeom>
           <a:solidFill>
-            <a:srgbClr val="FFFFFF">
-              <a:alpha val="92000"/>
-            </a:srgbClr>
+            <a:srgbClr val="FFFFFF"/>
           </a:solidFill>
           <a:ln/>
         </p:spPr>
@@ -28784,7 +28058,7 @@
             <a:avLst/>
           </a:prstGeom>
           <a:solidFill>
-            <a:srgbClr val="6FBE9C"/>
+            <a:srgbClr val="2E9284"/>
           </a:solidFill>
           <a:ln/>
         </p:spPr>
@@ -28840,7 +28114,7 @@
             <a:r>
               <a:rPr lang="en-US" sz="1500" b="1" dirty="0">
                 <a:solidFill>
-                  <a:srgbClr val="FFFFFF"/>
+                  <a:srgbClr val="2C7A6B"/>
                 </a:solidFill>
                 <a:latin typeface="Cambria" pitchFamily="34" charset="0"/>
                 <a:ea typeface="Cambria" pitchFamily="34" charset="-122"/>
@@ -28879,7 +28153,7 @@
             <a:r>
               <a:rPr lang="en-US" sz="1250" dirty="0">
                 <a:solidFill>
-                  <a:srgbClr val="EAF6EF"/>
+                  <a:srgbClr val="23423C"/>
                 </a:solidFill>
                 <a:latin typeface="Calibri" pitchFamily="34" charset="0"/>
                 <a:ea typeface="Calibri" pitchFamily="34" charset="-122"/>
@@ -28908,9 +28182,7 @@
             </a:avLst>
           </a:prstGeom>
           <a:solidFill>
-            <a:srgbClr val="FFFFFF">
-              <a:alpha val="92000"/>
-            </a:srgbClr>
+            <a:srgbClr val="FFFFFF"/>
           </a:solidFill>
           <a:ln/>
         </p:spPr>
@@ -28930,7 +28202,7 @@
             <a:avLst/>
           </a:prstGeom>
           <a:solidFill>
-            <a:srgbClr val="6FBE9C"/>
+            <a:srgbClr val="2E9284"/>
           </a:solidFill>
           <a:ln/>
         </p:spPr>
@@ -28986,7 +28258,7 @@
             <a:r>
               <a:rPr lang="en-US" sz="1500" b="1" dirty="0">
                 <a:solidFill>
-                  <a:srgbClr val="FFFFFF"/>
+                  <a:srgbClr val="2C7A6B"/>
                 </a:solidFill>
                 <a:latin typeface="Cambria" pitchFamily="34" charset="0"/>
                 <a:ea typeface="Cambria" pitchFamily="34" charset="-122"/>
@@ -29025,7 +28297,7 @@
             <a:r>
               <a:rPr lang="en-US" sz="1250" dirty="0">
                 <a:solidFill>
-                  <a:srgbClr val="EAF6EF"/>
+                  <a:srgbClr val="23423C"/>
                 </a:solidFill>
                 <a:latin typeface="Calibri" pitchFamily="34" charset="0"/>
                 <a:ea typeface="Calibri" pitchFamily="34" charset="-122"/>
@@ -30434,7 +29706,7 @@
       </p:grpSpPr>
       <p:pic>
         <p:nvPicPr>
-          <p:cNvPr id="2" name="Image 0" descr="/tmp/claude-0/-home-user-spanwerk-datenschutz/aecddc76-056b-54e2-a906-9229bc8dda84/scratchpad/final/bg_titel.jpg">    </p:cNvPr>
+          <p:cNvPr id="2" name="Image 0" descr="/tmp/claude-0/-home-user-spanwerk-datenschutz/aecddc76-056b-54e2-a906-9229bc8dda84/scratchpad/final/bg_titel_dark.jpg">    </p:cNvPr>
           <p:cNvPicPr>
             <a:picLocks noChangeAspect="1"/>
           </p:cNvPicPr>
@@ -30463,50 +29735,6 @@
         </p:nvSpPr>
         <p:spPr>
           <a:xfrm>
-            <a:off x="0" y="0"/>
-            <a:ext cx="12191695" cy="6858000"/>
-          </a:xfrm>
-          <a:prstGeom prst="rect">
-            <a:avLst/>
-          </a:prstGeom>
-          <a:solidFill>
-            <a:srgbClr val="24685C">
-              <a:alpha val="80000"/>
-            </a:srgbClr>
-          </a:solidFill>
-          <a:ln/>
-        </p:spPr>
-      </p:sp>
-      <p:sp>
-        <p:nvSpPr>
-          <p:cNvPr id="4" name="Shape 1"/>
-          <p:cNvSpPr/>
-          <p:nvPr/>
-        </p:nvSpPr>
-        <p:spPr>
-          <a:xfrm>
-            <a:off x="0" y="0"/>
-            <a:ext cx="12191695" cy="6858000"/>
-          </a:xfrm>
-          <a:prstGeom prst="rect">
-            <a:avLst/>
-          </a:prstGeom>
-          <a:solidFill>
-            <a:srgbClr val="24685C">
-              <a:alpha val="84000"/>
-            </a:srgbClr>
-          </a:solidFill>
-          <a:ln/>
-        </p:spPr>
-      </p:sp>
-      <p:sp>
-        <p:nvSpPr>
-          <p:cNvPr id="5" name="Shape 2"/>
-          <p:cNvSpPr/>
-          <p:nvPr/>
-        </p:nvSpPr>
-        <p:spPr>
-          <a:xfrm>
             <a:off x="5547208" y="1234440"/>
             <a:ext cx="1097280" cy="1097280"/>
           </a:xfrm>
@@ -30521,7 +29749,7 @@
       </p:sp>
       <p:pic>
         <p:nvPicPr>
-          <p:cNvPr id="6" name="Image 1" descr="preencoded.png">    </p:cNvPr>
+          <p:cNvPr id="4" name="Image 1" descr="preencoded.png">    </p:cNvPr>
           <p:cNvPicPr>
             <a:picLocks noChangeAspect="1"/>
           </p:cNvPicPr>
@@ -30545,7 +29773,7 @@
       </p:pic>
       <p:sp>
         <p:nvSpPr>
-          <p:cNvPr id="7" name="Text 3"/>
+          <p:cNvPr id="5" name="Text 1"/>
           <p:cNvSpPr/>
           <p:nvPr/>
         </p:nvSpPr>
@@ -30584,7 +29812,7 @@
       </p:sp>
       <p:sp>
         <p:nvSpPr>
-          <p:cNvPr id="8" name="Text 4"/>
+          <p:cNvPr id="6" name="Text 2"/>
           <p:cNvSpPr/>
           <p:nvPr/>
         </p:nvSpPr>
@@ -30646,7 +29874,7 @@
       </p:sp>
       <p:sp>
         <p:nvSpPr>
-          <p:cNvPr id="9" name="Text 5"/>
+          <p:cNvPr id="7" name="Text 3"/>
           <p:cNvSpPr/>
           <p:nvPr/>
         </p:nvSpPr>
@@ -30685,7 +29913,7 @@
       </p:sp>
       <p:sp>
         <p:nvSpPr>
-          <p:cNvPr id="11" name="Text 6"/>
+          <p:cNvPr id="9" name="Text 4"/>
           <p:cNvSpPr/>
           <p:nvPr/>
         </p:nvSpPr>
@@ -30724,7 +29952,7 @@
       </p:sp>
       <p:sp>
         <p:nvSpPr>
-          <p:cNvPr id="12" name="Text 7"/>
+          <p:cNvPr id="10" name="Text 5"/>
           <p:cNvSpPr/>
           <p:nvPr/>
         </p:nvSpPr>
@@ -30788,7 +30016,7 @@
       </p:grpSpPr>
       <p:pic>
         <p:nvPicPr>
-          <p:cNvPr id="2" name="Image 0" descr="/tmp/claude-0/-home-user-spanwerk-datenschutz/aecddc76-056b-54e2-a906-9229bc8dda84/scratchpad/final/bg_natur.jpg">    </p:cNvPr>
+          <p:cNvPr id="2" name="Image 0" descr="/tmp/claude-0/-home-user-spanwerk-datenschutz/aecddc76-056b-54e2-a906-9229bc8dda84/scratchpad/final/bg_natur_dark.jpg">    </p:cNvPr>
           <p:cNvPicPr>
             <a:picLocks noChangeAspect="1"/>
           </p:cNvPicPr>
@@ -30811,51 +30039,7 @@
       </p:pic>
       <p:sp>
         <p:nvSpPr>
-          <p:cNvPr id="3" name="Shape 0"/>
-          <p:cNvSpPr/>
-          <p:nvPr/>
-        </p:nvSpPr>
-        <p:spPr>
-          <a:xfrm>
-            <a:off x="0" y="0"/>
-            <a:ext cx="12191695" cy="6858000"/>
-          </a:xfrm>
-          <a:prstGeom prst="rect">
-            <a:avLst/>
-          </a:prstGeom>
-          <a:solidFill>
-            <a:srgbClr val="24685C">
-              <a:alpha val="84000"/>
-            </a:srgbClr>
-          </a:solidFill>
-          <a:ln/>
-        </p:spPr>
-      </p:sp>
-      <p:sp>
-        <p:nvSpPr>
-          <p:cNvPr id="4" name="Shape 1"/>
-          <p:cNvSpPr/>
-          <p:nvPr/>
-        </p:nvSpPr>
-        <p:spPr>
-          <a:xfrm>
-            <a:off x="0" y="0"/>
-            <a:ext cx="12191695" cy="6858000"/>
-          </a:xfrm>
-          <a:prstGeom prst="rect">
-            <a:avLst/>
-          </a:prstGeom>
-          <a:solidFill>
-            <a:srgbClr val="24685C">
-              <a:alpha val="88000"/>
-            </a:srgbClr>
-          </a:solidFill>
-          <a:ln/>
-        </p:spPr>
-      </p:sp>
-      <p:sp>
-        <p:nvSpPr>
-          <p:cNvPr id="5" name="Text 2"/>
+          <p:cNvPr id="3" name="Text 0"/>
           <p:cNvSpPr/>
           <p:nvPr/>
         </p:nvSpPr>
@@ -30894,7 +30078,7 @@
       </p:sp>
       <p:sp>
         <p:nvSpPr>
-          <p:cNvPr id="6" name="Text 3"/>
+          <p:cNvPr id="4" name="Text 1"/>
           <p:cNvSpPr/>
           <p:nvPr/>
         </p:nvSpPr>
@@ -30956,7 +30140,7 @@
       </p:sp>
       <p:sp>
         <p:nvSpPr>
-          <p:cNvPr id="7" name="Shape 4"/>
+          <p:cNvPr id="5" name="Shape 2"/>
           <p:cNvSpPr/>
           <p:nvPr/>
         </p:nvSpPr>
@@ -30971,16 +30155,14 @@
             </a:avLst>
           </a:prstGeom>
           <a:solidFill>
-            <a:srgbClr val="FFFFFF">
-              <a:alpha val="92000"/>
-            </a:srgbClr>
+            <a:srgbClr val="FFFFFF"/>
           </a:solidFill>
           <a:ln/>
         </p:spPr>
       </p:sp>
       <p:sp>
         <p:nvSpPr>
-          <p:cNvPr id="8" name="Shape 5"/>
+          <p:cNvPr id="6" name="Shape 3"/>
           <p:cNvSpPr/>
           <p:nvPr/>
         </p:nvSpPr>
@@ -31000,7 +30182,7 @@
       </p:sp>
       <p:pic>
         <p:nvPicPr>
-          <p:cNvPr id="9" name="Image 1" descr="preencoded.png">    </p:cNvPr>
+          <p:cNvPr id="7" name="Image 1" descr="preencoded.png">    </p:cNvPr>
           <p:cNvPicPr>
             <a:picLocks noChangeAspect="1"/>
           </p:cNvPicPr>
@@ -31024,7 +30206,7 @@
       </p:pic>
       <p:sp>
         <p:nvSpPr>
-          <p:cNvPr id="10" name="Text 6"/>
+          <p:cNvPr id="8" name="Text 4"/>
           <p:cNvSpPr/>
           <p:nvPr/>
         </p:nvSpPr>
@@ -31063,7 +30245,7 @@
       </p:sp>
       <p:sp>
         <p:nvSpPr>
-          <p:cNvPr id="11" name="Text 7"/>
+          <p:cNvPr id="9" name="Text 5"/>
           <p:cNvSpPr/>
           <p:nvPr/>
         </p:nvSpPr>
@@ -31102,7 +30284,7 @@
       </p:sp>
       <p:sp>
         <p:nvSpPr>
-          <p:cNvPr id="12" name="Shape 8"/>
+          <p:cNvPr id="10" name="Shape 6"/>
           <p:cNvSpPr/>
           <p:nvPr/>
         </p:nvSpPr>
@@ -31117,16 +30299,14 @@
             </a:avLst>
           </a:prstGeom>
           <a:solidFill>
-            <a:srgbClr val="FFFFFF">
-              <a:alpha val="92000"/>
-            </a:srgbClr>
+            <a:srgbClr val="FFFFFF"/>
           </a:solidFill>
           <a:ln/>
         </p:spPr>
       </p:sp>
       <p:sp>
         <p:nvSpPr>
-          <p:cNvPr id="13" name="Shape 9"/>
+          <p:cNvPr id="11" name="Shape 7"/>
           <p:cNvSpPr/>
           <p:nvPr/>
         </p:nvSpPr>
@@ -31146,7 +30326,7 @@
       </p:sp>
       <p:pic>
         <p:nvPicPr>
-          <p:cNvPr id="14" name="Image 2" descr="preencoded.png">    </p:cNvPr>
+          <p:cNvPr id="12" name="Image 2" descr="preencoded.png">    </p:cNvPr>
           <p:cNvPicPr>
             <a:picLocks noChangeAspect="1"/>
           </p:cNvPicPr>
@@ -31170,7 +30350,7 @@
       </p:pic>
       <p:sp>
         <p:nvSpPr>
-          <p:cNvPr id="15" name="Text 10"/>
+          <p:cNvPr id="13" name="Text 8"/>
           <p:cNvSpPr/>
           <p:nvPr/>
         </p:nvSpPr>
@@ -31209,7 +30389,7 @@
       </p:sp>
       <p:sp>
         <p:nvSpPr>
-          <p:cNvPr id="16" name="Text 11"/>
+          <p:cNvPr id="14" name="Text 9"/>
           <p:cNvSpPr/>
           <p:nvPr/>
         </p:nvSpPr>
@@ -31248,7 +30428,7 @@
       </p:sp>
       <p:sp>
         <p:nvSpPr>
-          <p:cNvPr id="17" name="Shape 12"/>
+          <p:cNvPr id="15" name="Shape 10"/>
           <p:cNvSpPr/>
           <p:nvPr/>
         </p:nvSpPr>
@@ -31263,16 +30443,14 @@
             </a:avLst>
           </a:prstGeom>
           <a:solidFill>
-            <a:srgbClr val="FFFFFF">
-              <a:alpha val="92000"/>
-            </a:srgbClr>
+            <a:srgbClr val="FFFFFF"/>
           </a:solidFill>
           <a:ln/>
         </p:spPr>
       </p:sp>
       <p:sp>
         <p:nvSpPr>
-          <p:cNvPr id="18" name="Shape 13"/>
+          <p:cNvPr id="16" name="Shape 11"/>
           <p:cNvSpPr/>
           <p:nvPr/>
         </p:nvSpPr>
@@ -31292,7 +30470,7 @@
       </p:sp>
       <p:pic>
         <p:nvPicPr>
-          <p:cNvPr id="19" name="Image 3" descr="preencoded.png">    </p:cNvPr>
+          <p:cNvPr id="17" name="Image 3" descr="preencoded.png">    </p:cNvPr>
           <p:cNvPicPr>
             <a:picLocks noChangeAspect="1"/>
           </p:cNvPicPr>
@@ -31316,7 +30494,7 @@
       </p:pic>
       <p:sp>
         <p:nvSpPr>
-          <p:cNvPr id="20" name="Text 14"/>
+          <p:cNvPr id="18" name="Text 12"/>
           <p:cNvSpPr/>
           <p:nvPr/>
         </p:nvSpPr>
@@ -31355,7 +30533,7 @@
       </p:sp>
       <p:sp>
         <p:nvSpPr>
-          <p:cNvPr id="21" name="Text 15"/>
+          <p:cNvPr id="19" name="Text 13"/>
           <p:cNvSpPr/>
           <p:nvPr/>
         </p:nvSpPr>
@@ -31394,7 +30572,7 @@
       </p:sp>
       <p:sp>
         <p:nvSpPr>
-          <p:cNvPr id="23" name="Text 16"/>
+          <p:cNvPr id="21" name="Text 14"/>
           <p:cNvSpPr/>
           <p:nvPr/>
         </p:nvSpPr>
@@ -31433,7 +30611,7 @@
       </p:sp>
       <p:sp>
         <p:nvSpPr>
-          <p:cNvPr id="24" name="Text 17"/>
+          <p:cNvPr id="22" name="Text 15"/>
           <p:cNvSpPr/>
           <p:nvPr/>
         </p:nvSpPr>
@@ -33184,7 +32362,7 @@
       </p:grpSpPr>
       <p:pic>
         <p:nvPicPr>
-          <p:cNvPr id="2" name="Image 0" descr="/tmp/claude-0/-home-user-spanwerk-datenschutz/aecddc76-056b-54e2-a906-9229bc8dda84/scratchpad/final/bg_natur.jpg">    </p:cNvPr>
+          <p:cNvPr id="2" name="Image 0" descr="/tmp/claude-0/-home-user-spanwerk-datenschutz/aecddc76-056b-54e2-a906-9229bc8dda84/scratchpad/final/bg_natur_dark.jpg">    </p:cNvPr>
           <p:cNvPicPr>
             <a:picLocks noChangeAspect="1"/>
           </p:cNvPicPr>
@@ -33207,29 +32385,7 @@
       </p:pic>
       <p:sp>
         <p:nvSpPr>
-          <p:cNvPr id="3" name="Shape 0"/>
-          <p:cNvSpPr/>
-          <p:nvPr/>
-        </p:nvSpPr>
-        <p:spPr>
-          <a:xfrm>
-            <a:off x="0" y="0"/>
-            <a:ext cx="12191695" cy="6858000"/>
-          </a:xfrm>
-          <a:prstGeom prst="rect">
-            <a:avLst/>
-          </a:prstGeom>
-          <a:solidFill>
-            <a:srgbClr val="24685C">
-              <a:alpha val="86000"/>
-            </a:srgbClr>
-          </a:solidFill>
-          <a:ln/>
-        </p:spPr>
-      </p:sp>
-      <p:sp>
-        <p:nvSpPr>
-          <p:cNvPr id="4" name="Text 1"/>
+          <p:cNvPr id="3" name="Text 0"/>
           <p:cNvSpPr/>
           <p:nvPr/>
         </p:nvSpPr>
@@ -33268,7 +32424,7 @@
       </p:sp>
       <p:sp>
         <p:nvSpPr>
-          <p:cNvPr id="5" name="Text 2"/>
+          <p:cNvPr id="4" name="Text 1"/>
           <p:cNvSpPr/>
           <p:nvPr/>
         </p:nvSpPr>
@@ -33307,7 +32463,7 @@
       </p:sp>
       <p:sp>
         <p:nvSpPr>
-          <p:cNvPr id="6" name="Shape 3"/>
+          <p:cNvPr id="5" name="Shape 2"/>
           <p:cNvSpPr/>
           <p:nvPr/>
         </p:nvSpPr>
@@ -33322,16 +32478,14 @@
             </a:avLst>
           </a:prstGeom>
           <a:solidFill>
-            <a:srgbClr val="FFFFFF">
-              <a:alpha val="94000"/>
-            </a:srgbClr>
+            <a:srgbClr val="FFFFFF"/>
           </a:solidFill>
           <a:ln/>
         </p:spPr>
       </p:sp>
       <p:sp>
         <p:nvSpPr>
-          <p:cNvPr id="7" name="Text 4"/>
+          <p:cNvPr id="6" name="Text 3"/>
           <p:cNvSpPr/>
           <p:nvPr/>
         </p:nvSpPr>
@@ -33370,7 +32524,7 @@
       </p:sp>
       <p:sp>
         <p:nvSpPr>
-          <p:cNvPr id="8" name="Text 5"/>
+          <p:cNvPr id="7" name="Text 4"/>
           <p:cNvSpPr/>
           <p:nvPr/>
         </p:nvSpPr>
@@ -33409,7 +32563,7 @@
       </p:sp>
       <p:sp>
         <p:nvSpPr>
-          <p:cNvPr id="9" name="Shape 6"/>
+          <p:cNvPr id="8" name="Shape 5"/>
           <p:cNvSpPr/>
           <p:nvPr/>
         </p:nvSpPr>
@@ -33424,16 +32578,14 @@
             </a:avLst>
           </a:prstGeom>
           <a:solidFill>
-            <a:srgbClr val="FFFFFF">
-              <a:alpha val="94000"/>
-            </a:srgbClr>
+            <a:srgbClr val="FFFFFF"/>
           </a:solidFill>
           <a:ln/>
         </p:spPr>
       </p:sp>
       <p:sp>
         <p:nvSpPr>
-          <p:cNvPr id="10" name="Text 7"/>
+          <p:cNvPr id="9" name="Text 6"/>
           <p:cNvSpPr/>
           <p:nvPr/>
         </p:nvSpPr>
@@ -33472,7 +32624,7 @@
       </p:sp>
       <p:sp>
         <p:nvSpPr>
-          <p:cNvPr id="11" name="Text 8"/>
+          <p:cNvPr id="10" name="Text 7"/>
           <p:cNvSpPr/>
           <p:nvPr/>
         </p:nvSpPr>
@@ -33511,7 +32663,7 @@
       </p:sp>
       <p:sp>
         <p:nvSpPr>
-          <p:cNvPr id="12" name="Shape 9"/>
+          <p:cNvPr id="11" name="Shape 8"/>
           <p:cNvSpPr/>
           <p:nvPr/>
         </p:nvSpPr>
@@ -33526,16 +32678,14 @@
             </a:avLst>
           </a:prstGeom>
           <a:solidFill>
-            <a:srgbClr val="FFFFFF">
-              <a:alpha val="94000"/>
-            </a:srgbClr>
+            <a:srgbClr val="FFFFFF"/>
           </a:solidFill>
           <a:ln/>
         </p:spPr>
       </p:sp>
       <p:sp>
         <p:nvSpPr>
-          <p:cNvPr id="13" name="Text 10"/>
+          <p:cNvPr id="12" name="Text 9"/>
           <p:cNvSpPr/>
           <p:nvPr/>
         </p:nvSpPr>
@@ -33574,7 +32724,7 @@
       </p:sp>
       <p:sp>
         <p:nvSpPr>
-          <p:cNvPr id="14" name="Text 11"/>
+          <p:cNvPr id="13" name="Text 10"/>
           <p:cNvSpPr/>
           <p:nvPr/>
         </p:nvSpPr>
@@ -33613,7 +32763,7 @@
       </p:sp>
       <p:sp>
         <p:nvSpPr>
-          <p:cNvPr id="15" name="Shape 12"/>
+          <p:cNvPr id="14" name="Shape 11"/>
           <p:cNvSpPr/>
           <p:nvPr/>
         </p:nvSpPr>
@@ -33628,16 +32778,14 @@
             </a:avLst>
           </a:prstGeom>
           <a:solidFill>
-            <a:srgbClr val="FFFFFF">
-              <a:alpha val="94000"/>
-            </a:srgbClr>
+            <a:srgbClr val="FFFFFF"/>
           </a:solidFill>
           <a:ln/>
         </p:spPr>
       </p:sp>
       <p:sp>
         <p:nvSpPr>
-          <p:cNvPr id="16" name="Text 13"/>
+          <p:cNvPr id="15" name="Text 12"/>
           <p:cNvSpPr/>
           <p:nvPr/>
         </p:nvSpPr>
@@ -33676,7 +32824,7 @@
       </p:sp>
       <p:sp>
         <p:nvSpPr>
-          <p:cNvPr id="17" name="Text 14"/>
+          <p:cNvPr id="16" name="Text 13"/>
           <p:cNvSpPr/>
           <p:nvPr/>
         </p:nvSpPr>
@@ -33715,7 +32863,7 @@
       </p:sp>
       <p:sp>
         <p:nvSpPr>
-          <p:cNvPr id="18" name="Text 15"/>
+          <p:cNvPr id="17" name="Text 14"/>
           <p:cNvSpPr/>
           <p:nvPr/>
         </p:nvSpPr>
@@ -33754,7 +32902,7 @@
       </p:sp>
       <p:sp>
         <p:nvSpPr>
-          <p:cNvPr id="20" name="Text 16"/>
+          <p:cNvPr id="19" name="Text 15"/>
           <p:cNvSpPr/>
           <p:nvPr/>
         </p:nvSpPr>
@@ -33793,7 +32941,7 @@
       </p:sp>
       <p:sp>
         <p:nvSpPr>
-          <p:cNvPr id="21" name="Text 17"/>
+          <p:cNvPr id="20" name="Text 16"/>
           <p:cNvSpPr/>
           <p:nvPr/>
         </p:nvSpPr>

</xml_diff>

<commit_message>
Folien 18 & 36 nach Lesbarkeitsprüfung korrigiert
Per selbst gebautem PPTX-Renderer visuell geprüft (LibreOffice ist gesperrt):
- Folie 18 (Eisberg): verborgene Begriffe stehen jetzt auf durchgehender
  deckender Fläche statt teils auf dem Foto; Wasserlinie-Label heller
- Folie 36 (Fachleute): grünes Feld vergrößert, Text nicht mehr abgeschnitten

Co-Authored-By: Claude Opus 4.8 <noreply@anthropic.com>
Claude-Session: https://claude.ai/code/session_01GYepHDnc6PQdCAJVNphDNw
</commit_message>
<xml_diff>
--- a/workshop-psychische-gesundheit/Foliensatz_Man-sieht-es-mir-nicht-an.pptx
+++ b/workshop-psychische-gesundheit/Foliensatz_Man-sieht-es-mir-nicht-an.pptx
@@ -10963,7 +10963,7 @@
         </p:nvSpPr>
         <p:spPr>
           <a:xfrm>
-            <a:off x="7680960" y="2377440"/>
+            <a:off x="7680960" y="2395728"/>
             <a:ext cx="4023360" cy="320040"/>
           </a:xfrm>
           <a:prstGeom prst="rect">
@@ -10980,9 +10980,9 @@
               <a:buNone/>
             </a:pPr>
             <a:r>
-              <a:rPr lang="en-US" sz="1150" i="1" dirty="0">
-                <a:solidFill>
-                  <a:srgbClr val="EAF6EF"/>
+              <a:rPr lang="en-US" sz="1250" i="1" dirty="0">
+                <a:solidFill>
+                  <a:srgbClr val="FFFFFF"/>
                 </a:solidFill>
                 <a:latin typeface="Calibri" pitchFamily="34" charset="0"/>
                 <a:ea typeface="Calibri" pitchFamily="34" charset="-122"/>
@@ -10990,7 +10990,7 @@
               </a:rPr>
               <a:t>Wasserlinie – was andere sehen</a:t>
             </a:r>
-            <a:endParaRPr lang="en-US" sz="1150" dirty="0"/>
+            <a:endParaRPr lang="en-US" sz="1250" dirty="0"/>
           </a:p>
         </p:txBody>
       </p:sp>
@@ -11002,8 +11002,8 @@
         </p:nvSpPr>
         <p:spPr>
           <a:xfrm flipV="1">
-            <a:off x="4480560" y="1600200"/>
-            <a:ext cx="3200400" cy="1188720"/>
+            <a:off x="4480560" y="1572768"/>
+            <a:ext cx="3200400" cy="1207008"/>
           </a:xfrm>
           <a:prstGeom prst="triangle">
             <a:avLst/>
@@ -11061,11 +11061,13 @@
         </p:nvSpPr>
         <p:spPr>
           <a:xfrm>
-            <a:off x="2377440" y="2834640"/>
-            <a:ext cx="7406640" cy="3063240"/>
-          </a:xfrm>
-          <a:prstGeom prst="triangle">
-            <a:avLst/>
+            <a:off x="1051560" y="3017520"/>
+            <a:ext cx="10104120" cy="2788920"/>
+          </a:xfrm>
+          <a:prstGeom prst="roundRect">
+            <a:avLst>
+              <a:gd name="adj" fmla="val 3934"/>
+            </a:avLst>
           </a:prstGeom>
           <a:solidFill>
             <a:srgbClr val="24685C"/>
@@ -11086,8 +11088,8 @@
         </p:nvSpPr>
         <p:spPr>
           <a:xfrm>
-            <a:off x="3291840" y="3108960"/>
-            <a:ext cx="3108960" cy="411480"/>
+            <a:off x="1417320" y="3154680"/>
+            <a:ext cx="9144000" cy="365760"/>
           </a:xfrm>
           <a:prstGeom prst="rect">
             <a:avLst/>
@@ -11103,7 +11105,46 @@
               <a:buNone/>
             </a:pPr>
             <a:r>
-              <a:rPr lang="en-US" sz="1550" dirty="0">
+              <a:rPr lang="en-US" sz="1300" i="1" dirty="0">
+                <a:solidFill>
+                  <a:srgbClr val="CFE6DC"/>
+                </a:solidFill>
+                <a:latin typeface="Calibri" pitchFamily="34" charset="0"/>
+                <a:ea typeface="Calibri" pitchFamily="34" charset="-122"/>
+                <a:cs typeface="Calibri" pitchFamily="34" charset="-120"/>
+              </a:rPr>
+              <a:t>Was darunter liegt – und niemand sieht:</a:t>
+            </a:r>
+            <a:endParaRPr lang="en-US" sz="1300" dirty="0"/>
+          </a:p>
+        </p:txBody>
+      </p:sp>
+      <p:sp>
+        <p:nvSpPr>
+          <p:cNvPr id="11" name="Text 8"/>
+          <p:cNvSpPr/>
+          <p:nvPr/>
+        </p:nvSpPr>
+        <p:spPr>
+          <a:xfrm>
+            <a:off x="1600200" y="3675888"/>
+            <a:ext cx="4663440" cy="411480"/>
+          </a:xfrm>
+          <a:prstGeom prst="rect">
+            <a:avLst/>
+          </a:prstGeom>
+          <a:noFill/>
+          <a:ln/>
+        </p:spPr>
+        <p:txBody>
+          <a:bodyPr wrap="square" rtlCol="0" anchor="ctr"/>
+          <a:lstStyle/>
+          <a:p>
+            <a:pPr indent="0" marL="0">
+              <a:buNone/>
+            </a:pPr>
+            <a:r>
+              <a:rPr lang="en-US" sz="1600" dirty="0">
                 <a:solidFill>
                   <a:srgbClr val="F2FAF5"/>
                 </a:solidFill>
@@ -11113,20 +11154,20 @@
               </a:rPr>
               <a:t>•  Erschöpfung</a:t>
             </a:r>
-            <a:endParaRPr lang="en-US" sz="1550" dirty="0"/>
-          </a:p>
-        </p:txBody>
-      </p:sp>
-      <p:sp>
-        <p:nvSpPr>
-          <p:cNvPr id="11" name="Text 8"/>
-          <p:cNvSpPr/>
-          <p:nvPr/>
-        </p:nvSpPr>
-        <p:spPr>
-          <a:xfrm>
-            <a:off x="6400800" y="3108960"/>
-            <a:ext cx="3108960" cy="411480"/>
+            <a:endParaRPr lang="en-US" sz="1600" dirty="0"/>
+          </a:p>
+        </p:txBody>
+      </p:sp>
+      <p:sp>
+        <p:nvSpPr>
+          <p:cNvPr id="12" name="Text 9"/>
+          <p:cNvSpPr/>
+          <p:nvPr/>
+        </p:nvSpPr>
+        <p:spPr>
+          <a:xfrm>
+            <a:off x="6446520" y="3675888"/>
+            <a:ext cx="4663440" cy="411480"/>
           </a:xfrm>
           <a:prstGeom prst="rect">
             <a:avLst/>
@@ -11142,7 +11183,7 @@
               <a:buNone/>
             </a:pPr>
             <a:r>
-              <a:rPr lang="en-US" sz="1550" dirty="0">
+              <a:rPr lang="en-US" sz="1600" dirty="0">
                 <a:solidFill>
                   <a:srgbClr val="F2FAF5"/>
                 </a:solidFill>
@@ -11152,20 +11193,20 @@
               </a:rPr>
               <a:t>•  Scham &amp; Schuld</a:t>
             </a:r>
-            <a:endParaRPr lang="en-US" sz="1550" dirty="0"/>
-          </a:p>
-        </p:txBody>
-      </p:sp>
-      <p:sp>
-        <p:nvSpPr>
-          <p:cNvPr id="12" name="Text 9"/>
-          <p:cNvSpPr/>
-          <p:nvPr/>
-        </p:nvSpPr>
-        <p:spPr>
-          <a:xfrm>
-            <a:off x="3291840" y="3675888"/>
-            <a:ext cx="3108960" cy="411480"/>
+            <a:endParaRPr lang="en-US" sz="1600" dirty="0"/>
+          </a:p>
+        </p:txBody>
+      </p:sp>
+      <p:sp>
+        <p:nvSpPr>
+          <p:cNvPr id="13" name="Text 10"/>
+          <p:cNvSpPr/>
+          <p:nvPr/>
+        </p:nvSpPr>
+        <p:spPr>
+          <a:xfrm>
+            <a:off x="1600200" y="4206240"/>
+            <a:ext cx="4663440" cy="411480"/>
           </a:xfrm>
           <a:prstGeom prst="rect">
             <a:avLst/>
@@ -11181,7 +11222,7 @@
               <a:buNone/>
             </a:pPr>
             <a:r>
-              <a:rPr lang="en-US" sz="1550" dirty="0">
+              <a:rPr lang="en-US" sz="1600" dirty="0">
                 <a:solidFill>
                   <a:srgbClr val="F2FAF5"/>
                 </a:solidFill>
@@ -11191,20 +11232,20 @@
               </a:rPr>
               <a:t>•  Angst</a:t>
             </a:r>
-            <a:endParaRPr lang="en-US" sz="1550" dirty="0"/>
-          </a:p>
-        </p:txBody>
-      </p:sp>
-      <p:sp>
-        <p:nvSpPr>
-          <p:cNvPr id="13" name="Text 10"/>
-          <p:cNvSpPr/>
-          <p:nvPr/>
-        </p:nvSpPr>
-        <p:spPr>
-          <a:xfrm>
-            <a:off x="6400800" y="3675888"/>
-            <a:ext cx="3108960" cy="411480"/>
+            <a:endParaRPr lang="en-US" sz="1600" dirty="0"/>
+          </a:p>
+        </p:txBody>
+      </p:sp>
+      <p:sp>
+        <p:nvSpPr>
+          <p:cNvPr id="14" name="Text 11"/>
+          <p:cNvSpPr/>
+          <p:nvPr/>
+        </p:nvSpPr>
+        <p:spPr>
+          <a:xfrm>
+            <a:off x="6446520" y="4206240"/>
+            <a:ext cx="4663440" cy="411480"/>
           </a:xfrm>
           <a:prstGeom prst="rect">
             <a:avLst/>
@@ -11220,7 +11261,7 @@
               <a:buNone/>
             </a:pPr>
             <a:r>
-              <a:rPr lang="en-US" sz="1550" dirty="0">
+              <a:rPr lang="en-US" sz="1600" dirty="0">
                 <a:solidFill>
                   <a:srgbClr val="F2FAF5"/>
                 </a:solidFill>
@@ -11230,20 +11271,20 @@
               </a:rPr>
               <a:t>•  innere Leere</a:t>
             </a:r>
-            <a:endParaRPr lang="en-US" sz="1550" dirty="0"/>
-          </a:p>
-        </p:txBody>
-      </p:sp>
-      <p:sp>
-        <p:nvSpPr>
-          <p:cNvPr id="14" name="Text 11"/>
-          <p:cNvSpPr/>
-          <p:nvPr/>
-        </p:nvSpPr>
-        <p:spPr>
-          <a:xfrm>
-            <a:off x="3291840" y="4242816"/>
-            <a:ext cx="3108960" cy="411480"/>
+            <a:endParaRPr lang="en-US" sz="1600" dirty="0"/>
+          </a:p>
+        </p:txBody>
+      </p:sp>
+      <p:sp>
+        <p:nvSpPr>
+          <p:cNvPr id="15" name="Text 12"/>
+          <p:cNvSpPr/>
+          <p:nvPr/>
+        </p:nvSpPr>
+        <p:spPr>
+          <a:xfrm>
+            <a:off x="1600200" y="4736592"/>
+            <a:ext cx="4663440" cy="411480"/>
           </a:xfrm>
           <a:prstGeom prst="rect">
             <a:avLst/>
@@ -11259,7 +11300,7 @@
               <a:buNone/>
             </a:pPr>
             <a:r>
-              <a:rPr lang="en-US" sz="1550" dirty="0">
+              <a:rPr lang="en-US" sz="1600" dirty="0">
                 <a:solidFill>
                   <a:srgbClr val="F2FAF5"/>
                 </a:solidFill>
@@ -11269,20 +11310,20 @@
               </a:rPr>
               <a:t>•  Selbstzweifel</a:t>
             </a:r>
-            <a:endParaRPr lang="en-US" sz="1550" dirty="0"/>
-          </a:p>
-        </p:txBody>
-      </p:sp>
-      <p:sp>
-        <p:nvSpPr>
-          <p:cNvPr id="15" name="Text 12"/>
-          <p:cNvSpPr/>
-          <p:nvPr/>
-        </p:nvSpPr>
-        <p:spPr>
-          <a:xfrm>
-            <a:off x="6400800" y="4242816"/>
-            <a:ext cx="3108960" cy="411480"/>
+            <a:endParaRPr lang="en-US" sz="1600" dirty="0"/>
+          </a:p>
+        </p:txBody>
+      </p:sp>
+      <p:sp>
+        <p:nvSpPr>
+          <p:cNvPr id="16" name="Text 13"/>
+          <p:cNvSpPr/>
+          <p:nvPr/>
+        </p:nvSpPr>
+        <p:spPr>
+          <a:xfrm>
+            <a:off x="6446520" y="4736592"/>
+            <a:ext cx="4663440" cy="411480"/>
           </a:xfrm>
           <a:prstGeom prst="rect">
             <a:avLst/>
@@ -11298,7 +11339,7 @@
               <a:buNone/>
             </a:pPr>
             <a:r>
-              <a:rPr lang="en-US" sz="1550" dirty="0">
+              <a:rPr lang="en-US" sz="1600" dirty="0">
                 <a:solidFill>
                   <a:srgbClr val="F2FAF5"/>
                 </a:solidFill>
@@ -11308,20 +11349,20 @@
               </a:rPr>
               <a:t>•  Einsamkeit</a:t>
             </a:r>
-            <a:endParaRPr lang="en-US" sz="1550" dirty="0"/>
-          </a:p>
-        </p:txBody>
-      </p:sp>
-      <p:sp>
-        <p:nvSpPr>
-          <p:cNvPr id="16" name="Text 13"/>
-          <p:cNvSpPr/>
-          <p:nvPr/>
-        </p:nvSpPr>
-        <p:spPr>
-          <a:xfrm>
-            <a:off x="3291840" y="4809744"/>
-            <a:ext cx="3108960" cy="411480"/>
+            <a:endParaRPr lang="en-US" sz="1600" dirty="0"/>
+          </a:p>
+        </p:txBody>
+      </p:sp>
+      <p:sp>
+        <p:nvSpPr>
+          <p:cNvPr id="17" name="Text 14"/>
+          <p:cNvSpPr/>
+          <p:nvPr/>
+        </p:nvSpPr>
+        <p:spPr>
+          <a:xfrm>
+            <a:off x="1600200" y="5266944"/>
+            <a:ext cx="4663440" cy="411480"/>
           </a:xfrm>
           <a:prstGeom prst="rect">
             <a:avLst/>
@@ -11337,7 +11378,7 @@
               <a:buNone/>
             </a:pPr>
             <a:r>
-              <a:rPr lang="en-US" sz="1550" dirty="0">
+              <a:rPr lang="en-US" sz="1600" dirty="0">
                 <a:solidFill>
                   <a:srgbClr val="F2FAF5"/>
                 </a:solidFill>
@@ -11347,13 +11388,13 @@
               </a:rPr>
               <a:t>•  „Ich funktioniere nur noch“</a:t>
             </a:r>
-            <a:endParaRPr lang="en-US" sz="1550" dirty="0"/>
-          </a:p>
-        </p:txBody>
-      </p:sp>
-      <p:sp>
-        <p:nvSpPr>
-          <p:cNvPr id="18" name="Text 14"/>
+            <a:endParaRPr lang="en-US" sz="1600" dirty="0"/>
+          </a:p>
+        </p:txBody>
+      </p:sp>
+      <p:sp>
+        <p:nvSpPr>
+          <p:cNvPr id="19" name="Text 15"/>
           <p:cNvSpPr/>
           <p:nvPr/>
         </p:nvSpPr>
@@ -11392,7 +11433,7 @@
       </p:sp>
       <p:sp>
         <p:nvSpPr>
-          <p:cNvPr id="19" name="Text 15"/>
+          <p:cNvPr id="20" name="Text 16"/>
           <p:cNvSpPr/>
           <p:nvPr/>
         </p:nvSpPr>
@@ -25861,12 +25902,12 @@
         </p:nvSpPr>
         <p:spPr>
           <a:xfrm>
-            <a:off x="566928" y="4343400"/>
-            <a:ext cx="11057839" cy="1417320"/>
+            <a:off x="566928" y="4206240"/>
+            <a:ext cx="11057839" cy="1700784"/>
           </a:xfrm>
           <a:prstGeom prst="roundRect">
             <a:avLst>
-              <a:gd name="adj" fmla="val 7742"/>
+              <a:gd name="adj" fmla="val 6452"/>
             </a:avLst>
           </a:prstGeom>
           <a:solidFill>
@@ -25883,7 +25924,7 @@
         </p:nvSpPr>
         <p:spPr>
           <a:xfrm>
-            <a:off x="932688" y="4617720"/>
+            <a:off x="932688" y="4663440"/>
             <a:ext cx="868680" cy="868680"/>
           </a:xfrm>
           <a:prstGeom prst="ellipse">
@@ -25911,7 +25952,7 @@
         </p:blipFill>
         <p:spPr>
           <a:xfrm>
-            <a:off x="1158545" y="4843577"/>
+            <a:off x="1158545" y="4889297"/>
             <a:ext cx="416966" cy="416966"/>
           </a:xfrm>
           <a:prstGeom prst="rect">
@@ -25927,8 +25968,8 @@
         </p:nvSpPr>
         <p:spPr>
           <a:xfrm>
-            <a:off x="2029968" y="4526280"/>
-            <a:ext cx="9229039" cy="1051560"/>
+            <a:off x="2029968" y="4315968"/>
+            <a:ext cx="9229039" cy="1463040"/>
           </a:xfrm>
           <a:prstGeom prst="rect">
             <a:avLst/>
@@ -25942,12 +25983,12 @@
           <a:p>
             <a:pPr indent="0" marL="0">
               <a:lnSpc>
-                <a:spcPts val="2400"/>
+                <a:spcPts val="2200"/>
               </a:lnSpc>
               <a:buNone/>
             </a:pPr>
             <a:r>
-              <a:rPr lang="en-US" sz="1900" b="1" dirty="0">
+              <a:rPr lang="en-US" sz="1800" b="1" dirty="0">
                 <a:solidFill>
                   <a:srgbClr val="FFFFFF"/>
                 </a:solidFill>
@@ -25955,24 +25996,24 @@
               <a:t>Hilfe anzunehmen ist keine Schwäche – es ist der mutigste und klügste Schritt.
 </a:t>
             </a:r>
-            <a:endParaRPr lang="en-US" sz="1900" dirty="0"/>
+            <a:endParaRPr lang="en-US" sz="1800" dirty="0"/>
           </a:p>
           <a:p>
             <a:pPr indent="0" marL="0">
               <a:lnSpc>
-                <a:spcPts val="2400"/>
+                <a:spcPts val="2200"/>
               </a:lnSpc>
               <a:buNone/>
             </a:pPr>
             <a:r>
-              <a:rPr lang="en-US" sz="1500" i="1" dirty="0">
+              <a:rPr lang="en-US" sz="1400" i="1" dirty="0">
                 <a:solidFill>
                   <a:srgbClr val="EAF6EF"/>
                 </a:solidFill>
               </a:rPr>
               <a:t>Zum Arzt oder in die Therapie zu gehen ist so normal wie zum Zahnarzt. Niemand muss das allein schaffen.</a:t>
             </a:r>
-            <a:endParaRPr lang="en-US" sz="1900" dirty="0"/>
+            <a:endParaRPr lang="en-US" sz="1800" dirty="0"/>
           </a:p>
         </p:txBody>
       </p:sp>

</xml_diff>